<commit_message>
Add Inspecciones SST and Evalúa SST apps; fix oval photos in PPTX
- Add two missing app cards (Inspecciones SST, Evalúa SST) to apps grid
- KPI counter now correctly reflects 10 total / 7 local / 3 external
- Remove rounding:true from all PPTX images (was causing oval/circular crop)
- All photos now display as rectangular with subtle border frame

Co-Authored-By: Claude Sonnet 4.6 <noreply@anthropic.com>
Claude-Session: https://claude.ai/code/session_01XvhWRdRzmvfoAaer6LAorC
</commit_message>
<xml_diff>
--- a/Reporte_SST_Semana36.pptx
+++ b/Reporte_SST_Semana36.pptx
@@ -1506,16 +1506,16 @@
         </p:nvSpPr>
         <p:spPr>
           <a:xfrm>
-            <a:off x="5943600" y="-1097280"/>
-            <a:ext cx="4572000" cy="4572000"/>
+            <a:off x="5760720" y="-1188720"/>
+            <a:ext cx="4754880" cy="4754880"/>
           </a:xfrm>
           <a:prstGeom prst="ellipse">
             <a:avLst/>
           </a:prstGeom>
-          <a:ln w="3810">
+          <a:ln w="5080">
             <a:solidFill>
               <a:srgbClr val="FFFFFF">
-                <a:alpha val="6000"/>
+                <a:alpha val="7000"/>
               </a:srgbClr>
             </a:solidFill>
             <a:prstDash val="solid"/>
@@ -1530,16 +1530,16 @@
         </p:nvSpPr>
         <p:spPr>
           <a:xfrm>
-            <a:off x="6583680" y="-457200"/>
-            <a:ext cx="3200400" cy="3200400"/>
+            <a:off x="6492240" y="-457200"/>
+            <a:ext cx="3291840" cy="3291840"/>
           </a:xfrm>
           <a:prstGeom prst="ellipse">
             <a:avLst/>
           </a:prstGeom>
-          <a:ln w="3810">
+          <a:ln w="5080">
             <a:solidFill>
               <a:srgbClr val="FFFFFF">
-                <a:alpha val="10000"/>
+                <a:alpha val="12000"/>
               </a:srgbClr>
             </a:solidFill>
             <a:prstDash val="solid"/>
@@ -1554,7 +1554,7 @@
         </p:nvSpPr>
         <p:spPr>
           <a:xfrm>
-            <a:off x="640080" y="1097280"/>
+            <a:off x="640080" y="1051560"/>
             <a:ext cx="7863840" cy="237744"/>
           </a:xfrm>
           <a:prstGeom prst="rect">
@@ -1593,8 +1593,8 @@
         </p:nvSpPr>
         <p:spPr>
           <a:xfrm>
-            <a:off x="640080" y="1371600"/>
-            <a:ext cx="7863840" cy="1463040"/>
+            <a:off x="640080" y="1298448"/>
+            <a:ext cx="7863840" cy="1508760"/>
           </a:xfrm>
           <a:prstGeom prst="rect">
             <a:avLst/>
@@ -1655,7 +1655,7 @@
         </p:nvSpPr>
         <p:spPr>
           <a:xfrm>
-            <a:off x="640080" y="2834640"/>
+            <a:off x="640080" y="2816352"/>
             <a:ext cx="7863840" cy="457200"/>
           </a:xfrm>
           <a:prstGeom prst="rect">
@@ -1694,7 +1694,7 @@
         </p:nvSpPr>
         <p:spPr>
           <a:xfrm>
-            <a:off x="640080" y="3291840"/>
+            <a:off x="640080" y="3273552"/>
             <a:ext cx="7863840" cy="201168"/>
           </a:xfrm>
           <a:prstGeom prst="rect">
@@ -1735,8 +1735,8 @@
         </p:nvSpPr>
         <p:spPr>
           <a:xfrm>
-            <a:off x="640080" y="3749040"/>
-            <a:ext cx="1988820" cy="219456"/>
+            <a:off x="640080" y="3730752"/>
+            <a:ext cx="1965960" cy="219456"/>
           </a:xfrm>
           <a:prstGeom prst="roundRect">
             <a:avLst>
@@ -1766,8 +1766,8 @@
         </p:nvSpPr>
         <p:spPr>
           <a:xfrm>
-            <a:off x="640080" y="3749040"/>
-            <a:ext cx="1988820" cy="219456"/>
+            <a:off x="640080" y="3730752"/>
+            <a:ext cx="1965960" cy="219456"/>
           </a:xfrm>
           <a:prstGeom prst="rect">
             <a:avLst/>
@@ -1805,8 +1805,8 @@
         </p:nvSpPr>
         <p:spPr>
           <a:xfrm>
-            <a:off x="2738628" y="3749040"/>
-            <a:ext cx="1371600" cy="219456"/>
+            <a:off x="2715768" y="3730752"/>
+            <a:ext cx="1356970" cy="219456"/>
           </a:xfrm>
           <a:prstGeom prst="roundRect">
             <a:avLst>
@@ -1836,8 +1836,8 @@
         </p:nvSpPr>
         <p:spPr>
           <a:xfrm>
-            <a:off x="2738628" y="3749040"/>
-            <a:ext cx="1371600" cy="219456"/>
+            <a:off x="2715768" y="3730752"/>
+            <a:ext cx="1356970" cy="219456"/>
           </a:xfrm>
           <a:prstGeom prst="rect">
             <a:avLst/>
@@ -1875,8 +1875,8 @@
         </p:nvSpPr>
         <p:spPr>
           <a:xfrm>
-            <a:off x="4219956" y="3749040"/>
-            <a:ext cx="1508760" cy="219456"/>
+            <a:off x="4182466" y="3730752"/>
+            <a:ext cx="1492301" cy="219456"/>
           </a:xfrm>
           <a:prstGeom prst="roundRect">
             <a:avLst>
@@ -1906,8 +1906,8 @@
         </p:nvSpPr>
         <p:spPr>
           <a:xfrm>
-            <a:off x="4219956" y="3749040"/>
-            <a:ext cx="1508760" cy="219456"/>
+            <a:off x="4182466" y="3730752"/>
+            <a:ext cx="1492301" cy="219456"/>
           </a:xfrm>
           <a:prstGeom prst="rect">
             <a:avLst/>
@@ -1945,8 +1945,8 @@
         </p:nvSpPr>
         <p:spPr>
           <a:xfrm>
-            <a:off x="5838444" y="3749040"/>
-            <a:ext cx="1851660" cy="219456"/>
+            <a:off x="5784494" y="3730752"/>
+            <a:ext cx="1830629" cy="219456"/>
           </a:xfrm>
           <a:prstGeom prst="roundRect">
             <a:avLst>
@@ -1976,8 +1976,8 @@
         </p:nvSpPr>
         <p:spPr>
           <a:xfrm>
-            <a:off x="5838444" y="3749040"/>
-            <a:ext cx="1851660" cy="219456"/>
+            <a:off x="5784494" y="3730752"/>
+            <a:ext cx="1830629" cy="219456"/>
           </a:xfrm>
           <a:prstGeom prst="rect">
             <a:avLst/>
@@ -2047,7 +2047,7 @@
         </p:nvSpPr>
         <p:spPr>
           <a:xfrm>
-            <a:off x="365760" y="228600"/>
+            <a:off x="365760" y="201168"/>
             <a:ext cx="8412480" cy="201168"/>
           </a:xfrm>
           <a:prstGeom prst="rect">
@@ -2125,8 +2125,8 @@
         </p:nvSpPr>
         <p:spPr>
           <a:xfrm>
-            <a:off x="365760" y="896112"/>
-            <a:ext cx="3246120" cy="201168"/>
+            <a:off x="365760" y="886968"/>
+            <a:ext cx="3163824" cy="201168"/>
           </a:xfrm>
           <a:prstGeom prst="roundRect">
             <a:avLst>
@@ -2153,19 +2153,19 @@
         <p:spPr>
           <a:xfrm>
             <a:off x="365760" y="886968"/>
-            <a:ext cx="8412480" cy="219456"/>
-          </a:xfrm>
-          <a:prstGeom prst="rect">
-            <a:avLst/>
-          </a:prstGeom>
-          <a:noFill/>
-          <a:ln/>
-        </p:spPr>
-        <p:txBody>
-          <a:bodyPr wrap="square" lIns="0" tIns="50800" rIns="50800" bIns="0" rtlCol="0" anchor="ctr"/>
-          <a:lstStyle/>
-          <a:p>
-            <a:pPr indent="0" marL="0">
+            <a:ext cx="3163824" cy="201168"/>
+          </a:xfrm>
+          <a:prstGeom prst="rect">
+            <a:avLst/>
+          </a:prstGeom>
+          <a:noFill/>
+          <a:ln/>
+        </p:spPr>
+        <p:txBody>
+          <a:bodyPr wrap="square" lIns="0" tIns="0" rIns="0" bIns="0" rtlCol="0" anchor="ctr"/>
+          <a:lstStyle/>
+          <a:p>
+            <a:pPr algn="ctr" indent="0" marL="0">
               <a:buNone/>
             </a:pPr>
             <a:r>
@@ -2192,7 +2192,7 @@
         <p:spPr>
           <a:xfrm>
             <a:off x="365760" y="1188720"/>
-            <a:ext cx="2514600" cy="1371600"/>
+            <a:ext cx="2542032" cy="1371600"/>
           </a:xfrm>
           <a:prstGeom prst="roundRect">
             <a:avLst>
@@ -2200,9 +2200,9 @@
             </a:avLst>
           </a:prstGeom>
           <a:solidFill>
-            <a:srgbClr val="000000"/>
-          </a:solidFill>
-          <a:ln w="12700">
+            <a:srgbClr val="FFFFFF"/>
+          </a:solidFill>
+          <a:ln w="10160">
             <a:solidFill>
               <a:srgbClr val="BBDEFB"/>
             </a:solidFill>
@@ -2220,16 +2220,15 @@
         </p:nvPicPr>
         <p:blipFill>
           <a:blip r:embed="rId1"/>
-          <a:stretch>
-            <a:fillRect/>
-          </a:stretch>
+          <a:srcRect l="0" r="0" t="0" b="0"/>
+          <a:stretch/>
         </p:blipFill>
         <p:spPr>
           <a:xfrm>
-            <a:off x="365760" y="1188720"/>
-            <a:ext cx="2514600" cy="1371600"/>
-          </a:xfrm>
-          <a:prstGeom prst="ellipse">
+            <a:off x="393192" y="1216152"/>
+            <a:ext cx="2487168" cy="1316736"/>
+          </a:xfrm>
+          <a:prstGeom prst="rect">
             <a:avLst/>
           </a:prstGeom>
         </p:spPr>
@@ -2242,8 +2241,8 @@
         </p:nvSpPr>
         <p:spPr>
           <a:xfrm>
-            <a:off x="365760" y="2587752"/>
-            <a:ext cx="2514600" cy="146304"/>
+            <a:off x="365760" y="2596896"/>
+            <a:ext cx="2542032" cy="146304"/>
           </a:xfrm>
           <a:prstGeom prst="rect">
             <a:avLst/>
@@ -2259,7 +2258,7 @@
               <a:buNone/>
             </a:pPr>
             <a:r>
-              <a:rPr lang="en-US" sz="700" b="1" spc="150" kern="0" dirty="0">
+              <a:rPr lang="en-US" sz="650" b="1" spc="150" kern="0" dirty="0">
                 <a:solidFill>
                   <a:srgbClr val="546E7A"/>
                 </a:solidFill>
@@ -2269,7 +2268,7 @@
               </a:rPr>
               <a:t>TABLERO ELÉCTRICO SCI</a:t>
             </a:r>
-            <a:endParaRPr lang="en-US" sz="700" dirty="0"/>
+            <a:endParaRPr lang="en-US" sz="650" dirty="0"/>
           </a:p>
         </p:txBody>
       </p:sp>
@@ -2281,8 +2280,8 @@
         </p:nvSpPr>
         <p:spPr>
           <a:xfrm>
-            <a:off x="2990088" y="1188720"/>
-            <a:ext cx="2514600" cy="1371600"/>
+            <a:off x="3017520" y="1188720"/>
+            <a:ext cx="2542032" cy="1371600"/>
           </a:xfrm>
           <a:prstGeom prst="roundRect">
             <a:avLst>
@@ -2290,9 +2289,9 @@
             </a:avLst>
           </a:prstGeom>
           <a:solidFill>
-            <a:srgbClr val="000000"/>
-          </a:solidFill>
-          <a:ln w="12700">
+            <a:srgbClr val="FFFFFF"/>
+          </a:solidFill>
+          <a:ln w="10160">
             <a:solidFill>
               <a:srgbClr val="BBDEFB"/>
             </a:solidFill>
@@ -2310,16 +2309,15 @@
         </p:nvPicPr>
         <p:blipFill>
           <a:blip r:embed="rId2"/>
-          <a:stretch>
-            <a:fillRect/>
-          </a:stretch>
+          <a:srcRect l="0" r="0" t="0" b="0"/>
+          <a:stretch/>
         </p:blipFill>
         <p:spPr>
           <a:xfrm>
-            <a:off x="2990088" y="1188720"/>
-            <a:ext cx="2514600" cy="1371600"/>
-          </a:xfrm>
-          <a:prstGeom prst="ellipse">
+            <a:off x="3044952" y="1216152"/>
+            <a:ext cx="2487168" cy="1316736"/>
+          </a:xfrm>
+          <a:prstGeom prst="rect">
             <a:avLst/>
           </a:prstGeom>
         </p:spPr>
@@ -2332,8 +2330,8 @@
         </p:nvSpPr>
         <p:spPr>
           <a:xfrm>
-            <a:off x="2990088" y="2587752"/>
-            <a:ext cx="2514600" cy="146304"/>
+            <a:off x="3017520" y="2596896"/>
+            <a:ext cx="2542032" cy="146304"/>
           </a:xfrm>
           <a:prstGeom prst="rect">
             <a:avLst/>
@@ -2349,7 +2347,7 @@
               <a:buNone/>
             </a:pPr>
             <a:r>
-              <a:rPr lang="en-US" sz="700" b="1" spc="150" kern="0" dirty="0">
+              <a:rPr lang="en-US" sz="650" b="1" spc="150" kern="0" dirty="0">
                 <a:solidFill>
                   <a:srgbClr val="546E7A"/>
                 </a:solidFill>
@@ -2359,7 +2357,7 @@
               </a:rPr>
               <a:t>INTERIOR — ANTES</a:t>
             </a:r>
-            <a:endParaRPr lang="en-US" sz="700" dirty="0"/>
+            <a:endParaRPr lang="en-US" sz="650" dirty="0"/>
           </a:p>
         </p:txBody>
       </p:sp>
@@ -2371,8 +2369,8 @@
         </p:nvSpPr>
         <p:spPr>
           <a:xfrm>
-            <a:off x="365760" y="2852928"/>
-            <a:ext cx="2514600" cy="1097280"/>
+            <a:off x="365760" y="2843784"/>
+            <a:ext cx="2542032" cy="1097280"/>
           </a:xfrm>
           <a:prstGeom prst="roundRect">
             <a:avLst>
@@ -2380,9 +2378,9 @@
             </a:avLst>
           </a:prstGeom>
           <a:solidFill>
-            <a:srgbClr val="000000"/>
-          </a:solidFill>
-          <a:ln w="12700">
+            <a:srgbClr val="FFFFFF"/>
+          </a:solidFill>
+          <a:ln w="10160">
             <a:solidFill>
               <a:srgbClr val="BBDEFB"/>
             </a:solidFill>
@@ -2400,16 +2398,15 @@
         </p:nvPicPr>
         <p:blipFill>
           <a:blip r:embed="rId3"/>
-          <a:stretch>
-            <a:fillRect/>
-          </a:stretch>
+          <a:srcRect l="0" r="0" t="0" b="0"/>
+          <a:stretch/>
         </p:blipFill>
         <p:spPr>
           <a:xfrm>
-            <a:off x="365760" y="2852928"/>
-            <a:ext cx="2514600" cy="1097280"/>
-          </a:xfrm>
-          <a:prstGeom prst="ellipse">
+            <a:off x="393192" y="2871216"/>
+            <a:ext cx="2487168" cy="1042416"/>
+          </a:xfrm>
+          <a:prstGeom prst="rect">
             <a:avLst/>
           </a:prstGeom>
         </p:spPr>
@@ -2423,7 +2420,7 @@
         <p:spPr>
           <a:xfrm>
             <a:off x="365760" y="3977640"/>
-            <a:ext cx="2514600" cy="146304"/>
+            <a:ext cx="2542032" cy="146304"/>
           </a:xfrm>
           <a:prstGeom prst="rect">
             <a:avLst/>
@@ -2439,7 +2436,7 @@
               <a:buNone/>
             </a:pPr>
             <a:r>
-              <a:rPr lang="en-US" sz="700" b="1" spc="150" kern="0" dirty="0">
+              <a:rPr lang="en-US" sz="650" b="1" spc="150" kern="0" dirty="0">
                 <a:solidFill>
                   <a:srgbClr val="546E7A"/>
                 </a:solidFill>
@@ -2449,7 +2446,7 @@
               </a:rPr>
               <a:t>INTERIOR — DESPUÉS</a:t>
             </a:r>
-            <a:endParaRPr lang="en-US" sz="700" dirty="0"/>
+            <a:endParaRPr lang="en-US" sz="650" dirty="0"/>
           </a:p>
         </p:txBody>
       </p:sp>
@@ -2461,8 +2458,8 @@
         </p:nvSpPr>
         <p:spPr>
           <a:xfrm>
-            <a:off x="2990088" y="2852928"/>
-            <a:ext cx="2514600" cy="1097280"/>
+            <a:off x="3017520" y="2843784"/>
+            <a:ext cx="2542032" cy="1097280"/>
           </a:xfrm>
           <a:prstGeom prst="roundRect">
             <a:avLst>
@@ -2470,9 +2467,9 @@
             </a:avLst>
           </a:prstGeom>
           <a:solidFill>
-            <a:srgbClr val="000000"/>
-          </a:solidFill>
-          <a:ln w="12700">
+            <a:srgbClr val="FFFFFF"/>
+          </a:solidFill>
+          <a:ln w="10160">
             <a:solidFill>
               <a:srgbClr val="BBDEFB"/>
             </a:solidFill>
@@ -2490,16 +2487,15 @@
         </p:nvPicPr>
         <p:blipFill>
           <a:blip r:embed="rId4"/>
-          <a:stretch>
-            <a:fillRect/>
-          </a:stretch>
+          <a:srcRect l="0" r="0" t="0" b="0"/>
+          <a:stretch/>
         </p:blipFill>
         <p:spPr>
           <a:xfrm>
-            <a:off x="2990088" y="2852928"/>
-            <a:ext cx="2514600" cy="1097280"/>
-          </a:xfrm>
-          <a:prstGeom prst="ellipse">
+            <a:off x="3044952" y="2871216"/>
+            <a:ext cx="2487168" cy="1042416"/>
+          </a:xfrm>
+          <a:prstGeom prst="rect">
             <a:avLst/>
           </a:prstGeom>
         </p:spPr>
@@ -2512,8 +2508,8 @@
         </p:nvSpPr>
         <p:spPr>
           <a:xfrm>
-            <a:off x="2990088" y="3977640"/>
-            <a:ext cx="2514600" cy="146304"/>
+            <a:off x="3017520" y="3977640"/>
+            <a:ext cx="2542032" cy="146304"/>
           </a:xfrm>
           <a:prstGeom prst="rect">
             <a:avLst/>
@@ -2529,7 +2525,7 @@
               <a:buNone/>
             </a:pPr>
             <a:r>
-              <a:rPr lang="en-US" sz="700" b="1" spc="150" kern="0" dirty="0">
+              <a:rPr lang="en-US" sz="650" b="1" spc="150" kern="0" dirty="0">
                 <a:solidFill>
                   <a:srgbClr val="546E7A"/>
                 </a:solidFill>
@@ -2539,7 +2535,7 @@
               </a:rPr>
               <a:t>DURANTE INTERVENCIÓN</a:t>
             </a:r>
-            <a:endParaRPr lang="en-US" sz="700" dirty="0"/>
+            <a:endParaRPr lang="en-US" sz="650" dirty="0"/>
           </a:p>
         </p:txBody>
       </p:sp>
@@ -2551,8 +2547,8 @@
         </p:nvSpPr>
         <p:spPr>
           <a:xfrm>
-            <a:off x="5852160" y="1188720"/>
-            <a:ext cx="2926080" cy="1097280"/>
+            <a:off x="5806440" y="1188720"/>
+            <a:ext cx="2971800" cy="1097280"/>
           </a:xfrm>
           <a:prstGeom prst="roundRect">
             <a:avLst>
@@ -2578,8 +2574,8 @@
         </p:nvSpPr>
         <p:spPr>
           <a:xfrm>
-            <a:off x="5961888" y="1298448"/>
-            <a:ext cx="2706624" cy="201168"/>
+            <a:off x="5925312" y="1289304"/>
+            <a:ext cx="2734056" cy="201168"/>
           </a:xfrm>
           <a:prstGeom prst="rect">
             <a:avLst/>
@@ -2617,7 +2613,7 @@
         </p:nvSpPr>
         <p:spPr>
           <a:xfrm>
-            <a:off x="5961888" y="1572768"/>
+            <a:off x="5925312" y="1545336"/>
             <a:ext cx="54864" cy="54864"/>
           </a:xfrm>
           <a:prstGeom prst="ellipse">
@@ -2642,8 +2638,8 @@
         </p:nvSpPr>
         <p:spPr>
           <a:xfrm>
-            <a:off x="6053328" y="1517904"/>
-            <a:ext cx="2596896" cy="164592"/>
+            <a:off x="6025896" y="1499616"/>
+            <a:ext cx="2624328" cy="164592"/>
           </a:xfrm>
           <a:prstGeom prst="rect">
             <a:avLst/>
@@ -2681,7 +2677,7 @@
         </p:nvSpPr>
         <p:spPr>
           <a:xfrm>
-            <a:off x="5961888" y="1746504"/>
+            <a:off x="5925312" y="1728216"/>
             <a:ext cx="54864" cy="54864"/>
           </a:xfrm>
           <a:prstGeom prst="ellipse">
@@ -2706,8 +2702,8 @@
         </p:nvSpPr>
         <p:spPr>
           <a:xfrm>
-            <a:off x="6053328" y="1691640"/>
-            <a:ext cx="2596896" cy="164592"/>
+            <a:off x="6025896" y="1682496"/>
+            <a:ext cx="2624328" cy="164592"/>
           </a:xfrm>
           <a:prstGeom prst="rect">
             <a:avLst/>
@@ -2745,7 +2741,7 @@
         </p:nvSpPr>
         <p:spPr>
           <a:xfrm>
-            <a:off x="5961888" y="1920240"/>
+            <a:off x="5925312" y="1911096"/>
             <a:ext cx="54864" cy="54864"/>
           </a:xfrm>
           <a:prstGeom prst="ellipse">
@@ -2770,8 +2766,8 @@
         </p:nvSpPr>
         <p:spPr>
           <a:xfrm>
-            <a:off x="6053328" y="1865376"/>
-            <a:ext cx="2596896" cy="164592"/>
+            <a:off x="6025896" y="1865376"/>
+            <a:ext cx="2624328" cy="164592"/>
           </a:xfrm>
           <a:prstGeom prst="rect">
             <a:avLst/>
@@ -2809,8 +2805,8 @@
         </p:nvSpPr>
         <p:spPr>
           <a:xfrm>
-            <a:off x="5961888" y="2075688"/>
-            <a:ext cx="2706624" cy="201168"/>
+            <a:off x="5925312" y="2084832"/>
+            <a:ext cx="2734056" cy="201168"/>
           </a:xfrm>
           <a:prstGeom prst="roundRect">
             <a:avLst>
@@ -2836,8 +2832,8 @@
         </p:nvSpPr>
         <p:spPr>
           <a:xfrm>
-            <a:off x="5961888" y="2075688"/>
-            <a:ext cx="2706624" cy="201168"/>
+            <a:off x="5925312" y="2084832"/>
+            <a:ext cx="2734056" cy="201168"/>
           </a:xfrm>
           <a:prstGeom prst="rect">
             <a:avLst/>
@@ -2875,12 +2871,12 @@
         </p:nvSpPr>
         <p:spPr>
           <a:xfrm>
-            <a:off x="5852160" y="2331720"/>
-            <a:ext cx="2926080" cy="548640"/>
+            <a:off x="5806440" y="2322576"/>
+            <a:ext cx="2971800" cy="530352"/>
           </a:xfrm>
           <a:prstGeom prst="roundRect">
             <a:avLst>
-              <a:gd name="adj" fmla="val 10000"/>
+              <a:gd name="adj" fmla="val 10345"/>
             </a:avLst>
           </a:prstGeom>
           <a:solidFill>
@@ -2902,8 +2898,8 @@
         </p:nvSpPr>
         <p:spPr>
           <a:xfrm>
-            <a:off x="5961888" y="2441448"/>
-            <a:ext cx="2706624" cy="201168"/>
+            <a:off x="5925312" y="2423160"/>
+            <a:ext cx="2734056" cy="201168"/>
           </a:xfrm>
           <a:prstGeom prst="rect">
             <a:avLst/>
@@ -2941,8 +2937,8 @@
         </p:nvSpPr>
         <p:spPr>
           <a:xfrm>
-            <a:off x="5961888" y="2679192"/>
-            <a:ext cx="2743200" cy="164592"/>
+            <a:off x="5925312" y="2651760"/>
+            <a:ext cx="2734056" cy="164592"/>
           </a:xfrm>
           <a:prstGeom prst="rect">
             <a:avLst/>
@@ -2980,12 +2976,12 @@
         </p:nvSpPr>
         <p:spPr>
           <a:xfrm>
-            <a:off x="5852160" y="2926080"/>
-            <a:ext cx="2926080" cy="1417320"/>
+            <a:off x="5806440" y="2889504"/>
+            <a:ext cx="2971800" cy="1435608"/>
           </a:xfrm>
           <a:prstGeom prst="roundRect">
             <a:avLst>
-              <a:gd name="adj" fmla="val 3871"/>
+              <a:gd name="adj" fmla="val 3822"/>
             </a:avLst>
           </a:prstGeom>
           <a:solidFill>
@@ -3007,8 +3003,8 @@
         </p:nvSpPr>
         <p:spPr>
           <a:xfrm>
-            <a:off x="5961888" y="3017520"/>
-            <a:ext cx="2706624" cy="201168"/>
+            <a:off x="5925312" y="2980944"/>
+            <a:ext cx="2734056" cy="201168"/>
           </a:xfrm>
           <a:prstGeom prst="rect">
             <a:avLst/>
@@ -3048,14 +3044,13 @@
         </p:nvPicPr>
         <p:blipFill>
           <a:blip r:embed="rId5"/>
-          <a:stretch>
-            <a:fillRect/>
-          </a:stretch>
+          <a:srcRect l="0" r="0" t="0" b="0"/>
+          <a:stretch/>
         </p:blipFill>
         <p:spPr>
           <a:xfrm>
-            <a:off x="5961888" y="3236976"/>
-            <a:ext cx="2706624" cy="996696"/>
+            <a:off x="5925312" y="3200400"/>
+            <a:ext cx="2734056" cy="1005840"/>
           </a:xfrm>
           <a:prstGeom prst="rect">
             <a:avLst/>
@@ -3102,7 +3097,7 @@
         </p:nvSpPr>
         <p:spPr>
           <a:xfrm>
-            <a:off x="365760" y="228600"/>
+            <a:off x="365760" y="201168"/>
             <a:ext cx="8412480" cy="201168"/>
           </a:xfrm>
           <a:prstGeom prst="rect">
@@ -3180,18 +3175,18 @@
         </p:nvSpPr>
         <p:spPr>
           <a:xfrm>
-            <a:off x="365760" y="1188720"/>
-            <a:ext cx="4160520" cy="2194560"/>
+            <a:off x="365760" y="1170432"/>
+            <a:ext cx="4160520" cy="2240280"/>
           </a:xfrm>
           <a:prstGeom prst="roundRect">
             <a:avLst>
-              <a:gd name="adj" fmla="val 2500"/>
+              <a:gd name="adj" fmla="val 2449"/>
             </a:avLst>
           </a:prstGeom>
           <a:solidFill>
-            <a:srgbClr val="000000"/>
-          </a:solidFill>
-          <a:ln w="12700">
+            <a:srgbClr val="FFFFFF"/>
+          </a:solidFill>
+          <a:ln w="10160">
             <a:solidFill>
               <a:srgbClr val="BBDEFB"/>
             </a:solidFill>
@@ -3209,16 +3204,15 @@
         </p:nvPicPr>
         <p:blipFill>
           <a:blip r:embed="rId1"/>
-          <a:stretch>
-            <a:fillRect/>
-          </a:stretch>
+          <a:srcRect l="0" r="0" t="0" b="0"/>
+          <a:stretch/>
         </p:blipFill>
         <p:spPr>
           <a:xfrm>
-            <a:off x="365760" y="1188720"/>
-            <a:ext cx="4160520" cy="2194560"/>
-          </a:xfrm>
-          <a:prstGeom prst="ellipse">
+            <a:off x="393192" y="1197864"/>
+            <a:ext cx="4105656" cy="2185416"/>
+          </a:xfrm>
+          <a:prstGeom prst="rect">
             <a:avLst/>
           </a:prstGeom>
         </p:spPr>
@@ -3231,7 +3225,7 @@
         </p:nvSpPr>
         <p:spPr>
           <a:xfrm>
-            <a:off x="365760" y="3383280"/>
+            <a:off x="365760" y="3410712"/>
             <a:ext cx="4160520" cy="1371600"/>
           </a:xfrm>
           <a:prstGeom prst="roundRect">
@@ -3258,7 +3252,7 @@
         </p:nvSpPr>
         <p:spPr>
           <a:xfrm>
-            <a:off x="475488" y="3493008"/>
+            <a:off x="475488" y="3511296"/>
             <a:ext cx="3941064" cy="201168"/>
           </a:xfrm>
           <a:prstGeom prst="rect">
@@ -3297,7 +3291,7 @@
         </p:nvSpPr>
         <p:spPr>
           <a:xfrm>
-            <a:off x="475488" y="3712464"/>
+            <a:off x="475488" y="3730752"/>
             <a:ext cx="3941064" cy="960120"/>
           </a:xfrm>
           <a:prstGeom prst="rect">
@@ -3339,18 +3333,18 @@
         </p:nvSpPr>
         <p:spPr>
           <a:xfrm>
-            <a:off x="4617720" y="1188720"/>
-            <a:ext cx="4160520" cy="2194560"/>
+            <a:off x="4617720" y="1170432"/>
+            <a:ext cx="4160520" cy="2240280"/>
           </a:xfrm>
           <a:prstGeom prst="roundRect">
             <a:avLst>
-              <a:gd name="adj" fmla="val 2500"/>
+              <a:gd name="adj" fmla="val 2449"/>
             </a:avLst>
           </a:prstGeom>
           <a:solidFill>
-            <a:srgbClr val="000000"/>
-          </a:solidFill>
-          <a:ln w="12700">
+            <a:srgbClr val="FFFFFF"/>
+          </a:solidFill>
+          <a:ln w="10160">
             <a:solidFill>
               <a:srgbClr val="BBDEFB"/>
             </a:solidFill>
@@ -3368,16 +3362,15 @@
         </p:nvPicPr>
         <p:blipFill>
           <a:blip r:embed="rId2"/>
-          <a:stretch>
-            <a:fillRect/>
-          </a:stretch>
+          <a:srcRect l="0" r="0" t="0" b="0"/>
+          <a:stretch/>
         </p:blipFill>
         <p:spPr>
           <a:xfrm>
-            <a:off x="4617720" y="1188720"/>
-            <a:ext cx="4160520" cy="2194560"/>
-          </a:xfrm>
-          <a:prstGeom prst="ellipse">
+            <a:off x="4645152" y="1197864"/>
+            <a:ext cx="4105656" cy="2185416"/>
+          </a:xfrm>
+          <a:prstGeom prst="rect">
             <a:avLst/>
           </a:prstGeom>
         </p:spPr>
@@ -3390,7 +3383,7 @@
         </p:nvSpPr>
         <p:spPr>
           <a:xfrm>
-            <a:off x="4617720" y="3383280"/>
+            <a:off x="4617720" y="3410712"/>
             <a:ext cx="4160520" cy="1371600"/>
           </a:xfrm>
           <a:prstGeom prst="roundRect">
@@ -3417,7 +3410,7 @@
         </p:nvSpPr>
         <p:spPr>
           <a:xfrm>
-            <a:off x="4727448" y="3493008"/>
+            <a:off x="4727448" y="3511296"/>
             <a:ext cx="3941064" cy="201168"/>
           </a:xfrm>
           <a:prstGeom prst="rect">
@@ -3456,7 +3449,7 @@
         </p:nvSpPr>
         <p:spPr>
           <a:xfrm>
-            <a:off x="4727448" y="3712464"/>
+            <a:off x="4727448" y="3730752"/>
             <a:ext cx="3941064" cy="960120"/>
           </a:xfrm>
           <a:prstGeom prst="rect">
@@ -3530,7 +3523,7 @@
         </p:nvSpPr>
         <p:spPr>
           <a:xfrm>
-            <a:off x="365760" y="228600"/>
+            <a:off x="365760" y="201168"/>
             <a:ext cx="8412480" cy="201168"/>
           </a:xfrm>
           <a:prstGeom prst="rect">
@@ -3594,7 +3587,7 @@
                 <a:ea typeface="Barlow Condensed" pitchFamily="34" charset="-122"/>
                 <a:cs typeface="Barlow Condensed" pitchFamily="34" charset="-120"/>
               </a:rPr>
-              <a:t>Prueba Operacional Semanal  Motobomba SCI</a:t>
+              <a:t>Prueba Operacional Semanal — Motobomba SCI</a:t>
             </a:r>
             <a:endParaRPr lang="en-US" sz="2400" dirty="0"/>
           </a:p>
@@ -3608,18 +3601,18 @@
         </p:nvSpPr>
         <p:spPr>
           <a:xfrm>
-            <a:off x="365760" y="1188720"/>
-            <a:ext cx="5029200" cy="3566160"/>
+            <a:off x="365760" y="1170432"/>
+            <a:ext cx="5029200" cy="3657600"/>
           </a:xfrm>
           <a:prstGeom prst="roundRect">
             <a:avLst>
-              <a:gd name="adj" fmla="val 1538"/>
+              <a:gd name="adj" fmla="val 1500"/>
             </a:avLst>
           </a:prstGeom>
           <a:solidFill>
-            <a:srgbClr val="000000"/>
-          </a:solidFill>
-          <a:ln w="12700">
+            <a:srgbClr val="FFFFFF"/>
+          </a:solidFill>
+          <a:ln w="10160">
             <a:solidFill>
               <a:srgbClr val="BBDEFB"/>
             </a:solidFill>
@@ -3637,16 +3630,15 @@
         </p:nvPicPr>
         <p:blipFill>
           <a:blip r:embed="rId1"/>
-          <a:stretch>
-            <a:fillRect/>
-          </a:stretch>
+          <a:srcRect l="0" r="0" t="0" b="0"/>
+          <a:stretch/>
         </p:blipFill>
         <p:spPr>
           <a:xfrm>
-            <a:off x="365760" y="1188720"/>
-            <a:ext cx="5029200" cy="3566160"/>
-          </a:xfrm>
-          <a:prstGeom prst="ellipse">
+            <a:off x="393192" y="1197864"/>
+            <a:ext cx="4974336" cy="3602736"/>
+          </a:xfrm>
+          <a:prstGeom prst="rect">
             <a:avLst/>
           </a:prstGeom>
         </p:spPr>
@@ -3659,8 +3651,8 @@
         </p:nvSpPr>
         <p:spPr>
           <a:xfrm>
-            <a:off x="5669280" y="1188720"/>
-            <a:ext cx="3108960" cy="1920240"/>
+            <a:off x="5623560" y="1170432"/>
+            <a:ext cx="3154680" cy="1920240"/>
           </a:xfrm>
           <a:prstGeom prst="roundRect">
             <a:avLst>
@@ -3686,8 +3678,8 @@
         </p:nvSpPr>
         <p:spPr>
           <a:xfrm>
-            <a:off x="5779008" y="1298448"/>
-            <a:ext cx="2889504" cy="201168"/>
+            <a:off x="5742432" y="1271016"/>
+            <a:ext cx="2916936" cy="201168"/>
           </a:xfrm>
           <a:prstGeom prst="rect">
             <a:avLst/>
@@ -3725,7 +3717,7 @@
         </p:nvSpPr>
         <p:spPr>
           <a:xfrm>
-            <a:off x="5779008" y="1572768"/>
+            <a:off x="5742432" y="1527048"/>
             <a:ext cx="54864" cy="54864"/>
           </a:xfrm>
           <a:prstGeom prst="ellipse">
@@ -3750,8 +3742,8 @@
         </p:nvSpPr>
         <p:spPr>
           <a:xfrm>
-            <a:off x="5870448" y="1517904"/>
-            <a:ext cx="2779776" cy="164592"/>
+            <a:off x="5843016" y="1481328"/>
+            <a:ext cx="2807208" cy="164592"/>
           </a:xfrm>
           <a:prstGeom prst="rect">
             <a:avLst/>
@@ -3789,7 +3781,7 @@
         </p:nvSpPr>
         <p:spPr>
           <a:xfrm>
-            <a:off x="5779008" y="1746504"/>
+            <a:off x="5742432" y="1709928"/>
             <a:ext cx="54864" cy="54864"/>
           </a:xfrm>
           <a:prstGeom prst="ellipse">
@@ -3814,8 +3806,8 @@
         </p:nvSpPr>
         <p:spPr>
           <a:xfrm>
-            <a:off x="5870448" y="1691640"/>
-            <a:ext cx="2779776" cy="164592"/>
+            <a:off x="5843016" y="1664208"/>
+            <a:ext cx="2807208" cy="164592"/>
           </a:xfrm>
           <a:prstGeom prst="rect">
             <a:avLst/>
@@ -3853,7 +3845,7 @@
         </p:nvSpPr>
         <p:spPr>
           <a:xfrm>
-            <a:off x="5779008" y="1920240"/>
+            <a:off x="5742432" y="1892808"/>
             <a:ext cx="54864" cy="54864"/>
           </a:xfrm>
           <a:prstGeom prst="ellipse">
@@ -3878,8 +3870,8 @@
         </p:nvSpPr>
         <p:spPr>
           <a:xfrm>
-            <a:off x="5870448" y="1865376"/>
-            <a:ext cx="2779776" cy="164592"/>
+            <a:off x="5843016" y="1847088"/>
+            <a:ext cx="2807208" cy="164592"/>
           </a:xfrm>
           <a:prstGeom prst="rect">
             <a:avLst/>
@@ -3917,7 +3909,7 @@
         </p:nvSpPr>
         <p:spPr>
           <a:xfrm>
-            <a:off x="5779008" y="2093976"/>
+            <a:off x="5742432" y="2075688"/>
             <a:ext cx="54864" cy="54864"/>
           </a:xfrm>
           <a:prstGeom prst="ellipse">
@@ -3942,8 +3934,8 @@
         </p:nvSpPr>
         <p:spPr>
           <a:xfrm>
-            <a:off x="5870448" y="2039112"/>
-            <a:ext cx="2779776" cy="164592"/>
+            <a:off x="5843016" y="2029968"/>
+            <a:ext cx="2807208" cy="164592"/>
           </a:xfrm>
           <a:prstGeom prst="rect">
             <a:avLst/>
@@ -3981,8 +3973,8 @@
         </p:nvSpPr>
         <p:spPr>
           <a:xfrm>
-            <a:off x="5779008" y="2249424"/>
-            <a:ext cx="2889504" cy="201168"/>
+            <a:off x="5742432" y="2249424"/>
+            <a:ext cx="2916936" cy="201168"/>
           </a:xfrm>
           <a:prstGeom prst="roundRect">
             <a:avLst>
@@ -4008,8 +4000,8 @@
         </p:nvSpPr>
         <p:spPr>
           <a:xfrm>
-            <a:off x="5779008" y="2249424"/>
-            <a:ext cx="2889504" cy="201168"/>
+            <a:off x="5742432" y="2249424"/>
+            <a:ext cx="2916936" cy="201168"/>
           </a:xfrm>
           <a:prstGeom prst="rect">
             <a:avLst/>
@@ -4047,12 +4039,12 @@
         </p:nvSpPr>
         <p:spPr>
           <a:xfrm>
-            <a:off x="5669280" y="3200400"/>
-            <a:ext cx="3108960" cy="1554480"/>
+            <a:off x="5623560" y="3145536"/>
+            <a:ext cx="3154680" cy="1682496"/>
           </a:xfrm>
           <a:prstGeom prst="roundRect">
             <a:avLst>
-              <a:gd name="adj" fmla="val 3529"/>
+              <a:gd name="adj" fmla="val 3261"/>
             </a:avLst>
           </a:prstGeom>
           <a:solidFill>
@@ -4074,8 +4066,8 @@
         </p:nvSpPr>
         <p:spPr>
           <a:xfrm>
-            <a:off x="5779008" y="3310128"/>
-            <a:ext cx="2889504" cy="201168"/>
+            <a:off x="5742432" y="3236976"/>
+            <a:ext cx="2916936" cy="201168"/>
           </a:xfrm>
           <a:prstGeom prst="rect">
             <a:avLst/>
@@ -4113,8 +4105,8 @@
         </p:nvSpPr>
         <p:spPr>
           <a:xfrm>
-            <a:off x="5779008" y="3401568"/>
-            <a:ext cx="2926080" cy="1188720"/>
+            <a:off x="5742432" y="3456432"/>
+            <a:ext cx="2916936" cy="1280160"/>
           </a:xfrm>
           <a:prstGeom prst="rect">
             <a:avLst/>
@@ -4128,7 +4120,7 @@
           <a:p>
             <a:pPr indent="0" marL="0">
               <a:lnSpc>
-                <a:spcPct val="135000"/>
+                <a:spcPct val="140000"/>
               </a:lnSpc>
               <a:buNone/>
             </a:pPr>
@@ -4187,7 +4179,7 @@
         </p:nvSpPr>
         <p:spPr>
           <a:xfrm>
-            <a:off x="365760" y="228600"/>
+            <a:off x="365760" y="201168"/>
             <a:ext cx="8412480" cy="201168"/>
           </a:xfrm>
           <a:prstGeom prst="rect">
@@ -4251,7 +4243,7 @@
                 <a:ea typeface="Barlow Condensed" pitchFamily="34" charset="-122"/>
                 <a:cs typeface="Barlow Condensed" pitchFamily="34" charset="-120"/>
               </a:rPr>
-              <a:t>Prueba de Ajuste y Capacitación  Respiradores ARMOR</a:t>
+              <a:t>Prueba de Ajuste y Capacitación — Respiradores ARMOR</a:t>
             </a:r>
             <a:endParaRPr lang="en-US" sz="2400" dirty="0"/>
           </a:p>
@@ -4265,18 +4257,18 @@
         </p:nvSpPr>
         <p:spPr>
           <a:xfrm>
-            <a:off x="365760" y="1143000"/>
-            <a:ext cx="2606040" cy="2011680"/>
+            <a:off x="365760" y="1115568"/>
+            <a:ext cx="2633472" cy="2057400"/>
           </a:xfrm>
           <a:prstGeom prst="roundRect">
             <a:avLst>
-              <a:gd name="adj" fmla="val 2727"/>
+              <a:gd name="adj" fmla="val 2667"/>
             </a:avLst>
           </a:prstGeom>
           <a:solidFill>
-            <a:srgbClr val="000000"/>
-          </a:solidFill>
-          <a:ln w="12700">
+            <a:srgbClr val="FFFFFF"/>
+          </a:solidFill>
+          <a:ln w="10160">
             <a:solidFill>
               <a:srgbClr val="BBDEFB"/>
             </a:solidFill>
@@ -4294,16 +4286,15 @@
         </p:nvPicPr>
         <p:blipFill>
           <a:blip r:embed="rId1"/>
-          <a:stretch>
-            <a:fillRect/>
-          </a:stretch>
+          <a:srcRect l="0" r="0" t="0" b="0"/>
+          <a:stretch/>
         </p:blipFill>
         <p:spPr>
           <a:xfrm>
-            <a:off x="365760" y="1143000"/>
-            <a:ext cx="2606040" cy="2011680"/>
-          </a:xfrm>
-          <a:prstGeom prst="ellipse">
+            <a:off x="393192" y="1143000"/>
+            <a:ext cx="2578608" cy="2002536"/>
+          </a:xfrm>
+          <a:prstGeom prst="rect">
             <a:avLst/>
           </a:prstGeom>
         </p:spPr>
@@ -4316,8 +4307,8 @@
         </p:nvSpPr>
         <p:spPr>
           <a:xfrm>
-            <a:off x="365760" y="3182112"/>
-            <a:ext cx="2606040" cy="146304"/>
+            <a:off x="365760" y="3209544"/>
+            <a:ext cx="2633472" cy="146304"/>
           </a:xfrm>
           <a:prstGeom prst="rect">
             <a:avLst/>
@@ -4333,7 +4324,7 @@
               <a:buNone/>
             </a:pPr>
             <a:r>
-              <a:rPr lang="en-US" sz="700" b="1" spc="150" kern="0" dirty="0">
+              <a:rPr lang="en-US" sz="650" b="1" spc="150" kern="0" dirty="0">
                 <a:solidFill>
                   <a:srgbClr val="546E7A"/>
                 </a:solidFill>
@@ -4343,7 +4334,7 @@
               </a:rPr>
               <a:t>CAPACITACIÓN AL PERSONAL</a:t>
             </a:r>
-            <a:endParaRPr lang="en-US" sz="700" dirty="0"/>
+            <a:endParaRPr lang="en-US" sz="650" dirty="0"/>
           </a:p>
         </p:txBody>
       </p:sp>
@@ -4355,18 +4346,18 @@
         </p:nvSpPr>
         <p:spPr>
           <a:xfrm>
-            <a:off x="3127248" y="1143000"/>
-            <a:ext cx="2606040" cy="2011680"/>
+            <a:off x="3154680" y="1115568"/>
+            <a:ext cx="2633472" cy="2057400"/>
           </a:xfrm>
           <a:prstGeom prst="roundRect">
             <a:avLst>
-              <a:gd name="adj" fmla="val 2727"/>
+              <a:gd name="adj" fmla="val 2667"/>
             </a:avLst>
           </a:prstGeom>
           <a:solidFill>
-            <a:srgbClr val="000000"/>
-          </a:solidFill>
-          <a:ln w="12700">
+            <a:srgbClr val="FFFFFF"/>
+          </a:solidFill>
+          <a:ln w="10160">
             <a:solidFill>
               <a:srgbClr val="BBDEFB"/>
             </a:solidFill>
@@ -4384,16 +4375,15 @@
         </p:nvPicPr>
         <p:blipFill>
           <a:blip r:embed="rId2"/>
-          <a:stretch>
-            <a:fillRect/>
-          </a:stretch>
+          <a:srcRect l="0" r="0" t="0" b="0"/>
+          <a:stretch/>
         </p:blipFill>
         <p:spPr>
           <a:xfrm>
-            <a:off x="3127248" y="1143000"/>
-            <a:ext cx="2606040" cy="2011680"/>
-          </a:xfrm>
-          <a:prstGeom prst="ellipse">
+            <a:off x="3182112" y="1143000"/>
+            <a:ext cx="2578608" cy="2002536"/>
+          </a:xfrm>
+          <a:prstGeom prst="rect">
             <a:avLst/>
           </a:prstGeom>
         </p:spPr>
@@ -4406,8 +4396,8 @@
         </p:nvSpPr>
         <p:spPr>
           <a:xfrm>
-            <a:off x="3127248" y="3182112"/>
-            <a:ext cx="2606040" cy="146304"/>
+            <a:off x="3154680" y="3209544"/>
+            <a:ext cx="2633472" cy="146304"/>
           </a:xfrm>
           <a:prstGeom prst="rect">
             <a:avLst/>
@@ -4423,7 +4413,7 @@
               <a:buNone/>
             </a:pPr>
             <a:r>
-              <a:rPr lang="en-US" sz="700" b="1" spc="150" kern="0" dirty="0">
+              <a:rPr lang="en-US" sz="650" b="1" spc="150" kern="0" dirty="0">
                 <a:solidFill>
                   <a:srgbClr val="546E7A"/>
                 </a:solidFill>
@@ -4433,7 +4423,7 @@
               </a:rPr>
               <a:t>PRUEBA DE AJUSTE INDIVIDUAL</a:t>
             </a:r>
-            <a:endParaRPr lang="en-US" sz="700" dirty="0"/>
+            <a:endParaRPr lang="en-US" sz="650" dirty="0"/>
           </a:p>
         </p:txBody>
       </p:sp>
@@ -4445,18 +4435,18 @@
         </p:nvSpPr>
         <p:spPr>
           <a:xfrm>
-            <a:off x="5888736" y="1143000"/>
-            <a:ext cx="2606040" cy="2011680"/>
+            <a:off x="5943600" y="1115568"/>
+            <a:ext cx="2633472" cy="2057400"/>
           </a:xfrm>
           <a:prstGeom prst="roundRect">
             <a:avLst>
-              <a:gd name="adj" fmla="val 2727"/>
+              <a:gd name="adj" fmla="val 2667"/>
             </a:avLst>
           </a:prstGeom>
           <a:solidFill>
-            <a:srgbClr val="000000"/>
-          </a:solidFill>
-          <a:ln w="12700">
+            <a:srgbClr val="FFFFFF"/>
+          </a:solidFill>
+          <a:ln w="10160">
             <a:solidFill>
               <a:srgbClr val="BBDEFB"/>
             </a:solidFill>
@@ -4474,16 +4464,15 @@
         </p:nvPicPr>
         <p:blipFill>
           <a:blip r:embed="rId3"/>
-          <a:stretch>
-            <a:fillRect/>
-          </a:stretch>
+          <a:srcRect l="0" r="0" t="0" b="0"/>
+          <a:stretch/>
         </p:blipFill>
         <p:spPr>
           <a:xfrm>
-            <a:off x="5888736" y="1143000"/>
-            <a:ext cx="2606040" cy="2011680"/>
-          </a:xfrm>
-          <a:prstGeom prst="ellipse">
+            <a:off x="5971032" y="1143000"/>
+            <a:ext cx="2578608" cy="2002536"/>
+          </a:xfrm>
+          <a:prstGeom prst="rect">
             <a:avLst/>
           </a:prstGeom>
         </p:spPr>
@@ -4496,8 +4485,8 @@
         </p:nvSpPr>
         <p:spPr>
           <a:xfrm>
-            <a:off x="5888736" y="3182112"/>
-            <a:ext cx="2606040" cy="146304"/>
+            <a:off x="5943600" y="3209544"/>
+            <a:ext cx="2633472" cy="146304"/>
           </a:xfrm>
           <a:prstGeom prst="rect">
             <a:avLst/>
@@ -4513,7 +4502,7 @@
               <a:buNone/>
             </a:pPr>
             <a:r>
-              <a:rPr lang="en-US" sz="700" b="1" spc="150" kern="0" dirty="0">
+              <a:rPr lang="en-US" sz="650" b="1" spc="150" kern="0" dirty="0">
                 <a:solidFill>
                   <a:srgbClr val="546E7A"/>
                 </a:solidFill>
@@ -4523,7 +4512,7 @@
               </a:rPr>
               <a:t>USO EN PLANTA</a:t>
             </a:r>
-            <a:endParaRPr lang="en-US" sz="700" dirty="0"/>
+            <a:endParaRPr lang="en-US" sz="650" dirty="0"/>
           </a:p>
         </p:txBody>
       </p:sp>
@@ -4535,12 +4524,12 @@
         </p:nvSpPr>
         <p:spPr>
           <a:xfrm>
-            <a:off x="365760" y="3383280"/>
-            <a:ext cx="8412480" cy="1508760"/>
+            <a:off x="365760" y="3410712"/>
+            <a:ext cx="8412480" cy="1481328"/>
           </a:xfrm>
           <a:prstGeom prst="roundRect">
             <a:avLst>
-              <a:gd name="adj" fmla="val 3636"/>
+              <a:gd name="adj" fmla="val 3704"/>
             </a:avLst>
           </a:prstGeom>
           <a:solidFill>
@@ -4562,8 +4551,8 @@
         </p:nvSpPr>
         <p:spPr>
           <a:xfrm>
-            <a:off x="475488" y="3493008"/>
-            <a:ext cx="8193024" cy="201168"/>
+            <a:off x="484632" y="3511296"/>
+            <a:ext cx="8174736" cy="201168"/>
           </a:xfrm>
           <a:prstGeom prst="rect">
             <a:avLst/>
@@ -4601,7 +4590,7 @@
         </p:nvSpPr>
         <p:spPr>
           <a:xfrm>
-            <a:off x="475488" y="3767328"/>
+            <a:off x="484632" y="3767328"/>
             <a:ext cx="54864" cy="54864"/>
           </a:xfrm>
           <a:prstGeom prst="ellipse">
@@ -4626,8 +4615,8 @@
         </p:nvSpPr>
         <p:spPr>
           <a:xfrm>
-            <a:off x="566928" y="3712464"/>
-            <a:ext cx="8083296" cy="164592"/>
+            <a:off x="585216" y="3721608"/>
+            <a:ext cx="8065008" cy="164592"/>
           </a:xfrm>
           <a:prstGeom prst="rect">
             <a:avLst/>
@@ -4651,7 +4640,7 @@
                 <a:ea typeface="Calibri" pitchFamily="34" charset="-122"/>
                 <a:cs typeface="Calibri" pitchFamily="34" charset="-120"/>
               </a:rPr>
-              <a:t>Selección del respirador según tarea</a:t>
+              <a:t>Selección del respirador según tarea · Técnica correcta de colocación</a:t>
             </a:r>
             <a:endParaRPr lang="en-US" sz="800" dirty="0"/>
           </a:p>
@@ -4665,7 +4654,7 @@
         </p:nvSpPr>
         <p:spPr>
           <a:xfrm>
-            <a:off x="475488" y="3941064"/>
+            <a:off x="484632" y="3950208"/>
             <a:ext cx="54864" cy="54864"/>
           </a:xfrm>
           <a:prstGeom prst="ellipse">
@@ -4690,8 +4679,8 @@
         </p:nvSpPr>
         <p:spPr>
           <a:xfrm>
-            <a:off x="566928" y="3886200"/>
-            <a:ext cx="8083296" cy="164592"/>
+            <a:off x="585216" y="3904488"/>
+            <a:ext cx="8065008" cy="164592"/>
           </a:xfrm>
           <a:prstGeom prst="rect">
             <a:avLst/>
@@ -4715,7 +4704,7 @@
                 <a:ea typeface="Calibri" pitchFamily="34" charset="-122"/>
                 <a:cs typeface="Calibri" pitchFamily="34" charset="-120"/>
               </a:rPr>
-              <a:t>Técnica correcta de colocación · Prueba de ajuste positiva y negativa</a:t>
+              <a:t>Prueba de ajuste positiva y negativa · Reconocimiento de vida útil del filtro</a:t>
             </a:r>
             <a:endParaRPr lang="en-US" sz="800" dirty="0"/>
           </a:p>
@@ -4729,7 +4718,7 @@
         </p:nvSpPr>
         <p:spPr>
           <a:xfrm>
-            <a:off x="475488" y="4114800"/>
+            <a:off x="484632" y="4133088"/>
             <a:ext cx="54864" cy="54864"/>
           </a:xfrm>
           <a:prstGeom prst="ellipse">
@@ -4754,8 +4743,8 @@
         </p:nvSpPr>
         <p:spPr>
           <a:xfrm>
-            <a:off x="566928" y="4059936"/>
-            <a:ext cx="8083296" cy="164592"/>
+            <a:off x="585216" y="4087368"/>
+            <a:ext cx="8065008" cy="164592"/>
           </a:xfrm>
           <a:prstGeom prst="rect">
             <a:avLst/>
@@ -4779,71 +4768,7 @@
                 <a:ea typeface="Calibri" pitchFamily="34" charset="-122"/>
                 <a:cs typeface="Calibri" pitchFamily="34" charset="-120"/>
               </a:rPr>
-              <a:t>Reconocimiento de vida útil del filtro · Almacenamiento y limpieza del equipo</a:t>
-            </a:r>
-            <a:endParaRPr lang="en-US" sz="800" dirty="0"/>
-          </a:p>
-        </p:txBody>
-      </p:sp>
-      <p:sp>
-        <p:nvSpPr>
-          <p:cNvPr id="21" name="Shape 16"/>
-          <p:cNvSpPr/>
-          <p:nvPr/>
-        </p:nvSpPr>
-        <p:spPr>
-          <a:xfrm>
-            <a:off x="475488" y="4288536"/>
-            <a:ext cx="54864" cy="54864"/>
-          </a:xfrm>
-          <a:prstGeom prst="ellipse">
-            <a:avLst/>
-          </a:prstGeom>
-          <a:solidFill>
-            <a:srgbClr val="1E88E5"/>
-          </a:solidFill>
-          <a:ln w="12700">
-            <a:solidFill>
-              <a:srgbClr val="1E88E5"/>
-            </a:solidFill>
-            <a:prstDash val="solid"/>
-          </a:ln>
-        </p:spPr>
-      </p:sp>
-      <p:sp>
-        <p:nvSpPr>
-          <p:cNvPr id="22" name="Text 17"/>
-          <p:cNvSpPr txBox="1"/>
-          <p:nvPr/>
-        </p:nvSpPr>
-        <p:spPr>
-          <a:xfrm>
-            <a:off x="566928" y="4233672"/>
-            <a:ext cx="8083296" cy="164592"/>
-          </a:xfrm>
-          <a:prstGeom prst="rect">
-            <a:avLst/>
-          </a:prstGeom>
-          <a:noFill/>
-          <a:ln/>
-        </p:spPr>
-        <p:txBody>
-          <a:bodyPr wrap="square" lIns="0" tIns="0" rIns="0" bIns="0" rtlCol="0" anchor="ctr"/>
-          <a:lstStyle/>
-          <a:p>
-            <a:pPr indent="0" marL="0">
-              <a:buNone/>
-            </a:pPr>
-            <a:r>
-              <a:rPr lang="en-US" sz="800" dirty="0">
-                <a:solidFill>
-                  <a:srgbClr val="546E7A"/>
-                </a:solidFill>
-                <a:latin typeface="Calibri" pitchFamily="34" charset="0"/>
-                <a:ea typeface="Calibri" pitchFamily="34" charset="-122"/>
-                <a:cs typeface="Calibri" pitchFamily="34" charset="-120"/>
-              </a:rPr>
-              <a:t>Marca ARMOR — certificación vigente</a:t>
+              <a:t>Almacenamiento y limpieza del equipo · Marca ARMOR — certificación vigente</a:t>
             </a:r>
             <a:endParaRPr lang="en-US" sz="800" dirty="0"/>
           </a:p>
@@ -4889,7 +4814,7 @@
         </p:nvSpPr>
         <p:spPr>
           <a:xfrm>
-            <a:off x="365760" y="228600"/>
+            <a:off x="365760" y="201168"/>
             <a:ext cx="8412480" cy="201168"/>
           </a:xfrm>
           <a:prstGeom prst="rect">
@@ -4967,8 +4892,8 @@
         </p:nvSpPr>
         <p:spPr>
           <a:xfrm>
-            <a:off x="365760" y="914400"/>
-            <a:ext cx="8412480" cy="292608"/>
+            <a:off x="365760" y="932688"/>
+            <a:ext cx="8412480" cy="274320"/>
           </a:xfrm>
           <a:prstGeom prst="rect">
             <a:avLst/>
@@ -5006,8 +4931,8 @@
         </p:nvSpPr>
         <p:spPr>
           <a:xfrm>
-            <a:off x="365760" y="1325880"/>
-            <a:ext cx="2560320" cy="1005840"/>
+            <a:off x="365760" y="1298448"/>
+            <a:ext cx="2523744" cy="1005840"/>
           </a:xfrm>
           <a:prstGeom prst="roundRect">
             <a:avLst>
@@ -5033,8 +4958,8 @@
         </p:nvSpPr>
         <p:spPr>
           <a:xfrm>
-            <a:off x="365760" y="1417320"/>
-            <a:ext cx="2560320" cy="502920"/>
+            <a:off x="365760" y="1371600"/>
+            <a:ext cx="2523744" cy="530352"/>
           </a:xfrm>
           <a:prstGeom prst="rect">
             <a:avLst/>
@@ -5050,7 +4975,7 @@
               <a:buNone/>
             </a:pPr>
             <a:r>
-              <a:rPr lang="en-US" sz="4000" b="1" dirty="0">
+              <a:rPr lang="en-US" sz="4200" b="1" dirty="0">
                 <a:solidFill>
                   <a:srgbClr val="90CAF9"/>
                 </a:solidFill>
@@ -5060,7 +4985,7 @@
               </a:rPr>
               <a:t>10</a:t>
             </a:r>
-            <a:endParaRPr lang="en-US" sz="4000" dirty="0"/>
+            <a:endParaRPr lang="en-US" sz="4200" dirty="0"/>
           </a:p>
         </p:txBody>
       </p:sp>
@@ -5072,8 +4997,8 @@
         </p:nvSpPr>
         <p:spPr>
           <a:xfrm>
-            <a:off x="365760" y="1920240"/>
-            <a:ext cx="2560320" cy="182880"/>
+            <a:off x="365760" y="1901952"/>
+            <a:ext cx="2523744" cy="182880"/>
           </a:xfrm>
           <a:prstGeom prst="rect">
             <a:avLst/>
@@ -5113,8 +5038,8 @@
         </p:nvSpPr>
         <p:spPr>
           <a:xfrm>
-            <a:off x="3127248" y="1325880"/>
-            <a:ext cx="2560320" cy="1005840"/>
+            <a:off x="3035808" y="1298448"/>
+            <a:ext cx="2523744" cy="1005840"/>
           </a:xfrm>
           <a:prstGeom prst="roundRect">
             <a:avLst>
@@ -5140,8 +5065,8 @@
         </p:nvSpPr>
         <p:spPr>
           <a:xfrm>
-            <a:off x="3127248" y="1417320"/>
-            <a:ext cx="2560320" cy="502920"/>
+            <a:off x="3035808" y="1371600"/>
+            <a:ext cx="2523744" cy="530352"/>
           </a:xfrm>
           <a:prstGeom prst="rect">
             <a:avLst/>
@@ -5157,7 +5082,7 @@
               <a:buNone/>
             </a:pPr>
             <a:r>
-              <a:rPr lang="en-US" sz="4000" b="1" dirty="0">
+              <a:rPr lang="en-US" sz="4200" b="1" dirty="0">
                 <a:solidFill>
                   <a:srgbClr val="90CAF9"/>
                 </a:solidFill>
@@ -5167,7 +5092,7 @@
               </a:rPr>
               <a:t>7</a:t>
             </a:r>
-            <a:endParaRPr lang="en-US" sz="4000" dirty="0"/>
+            <a:endParaRPr lang="en-US" sz="4200" dirty="0"/>
           </a:p>
         </p:txBody>
       </p:sp>
@@ -5179,8 +5104,8 @@
         </p:nvSpPr>
         <p:spPr>
           <a:xfrm>
-            <a:off x="3127248" y="1920240"/>
-            <a:ext cx="2560320" cy="182880"/>
+            <a:off x="3035808" y="1901952"/>
+            <a:ext cx="2523744" cy="182880"/>
           </a:xfrm>
           <a:prstGeom prst="rect">
             <a:avLst/>
@@ -5220,8 +5145,8 @@
         </p:nvSpPr>
         <p:spPr>
           <a:xfrm>
-            <a:off x="5888736" y="1325880"/>
-            <a:ext cx="2560320" cy="1005840"/>
+            <a:off x="5705856" y="1298448"/>
+            <a:ext cx="2523744" cy="1005840"/>
           </a:xfrm>
           <a:prstGeom prst="roundRect">
             <a:avLst>
@@ -5247,8 +5172,8 @@
         </p:nvSpPr>
         <p:spPr>
           <a:xfrm>
-            <a:off x="5888736" y="1417320"/>
-            <a:ext cx="2560320" cy="502920"/>
+            <a:off x="5705856" y="1371600"/>
+            <a:ext cx="2523744" cy="530352"/>
           </a:xfrm>
           <a:prstGeom prst="rect">
             <a:avLst/>
@@ -5264,7 +5189,7 @@
               <a:buNone/>
             </a:pPr>
             <a:r>
-              <a:rPr lang="en-US" sz="4000" b="1" dirty="0">
+              <a:rPr lang="en-US" sz="4200" b="1" dirty="0">
                 <a:solidFill>
                   <a:srgbClr val="90CAF9"/>
                 </a:solidFill>
@@ -5274,7 +5199,7 @@
               </a:rPr>
               <a:t>3</a:t>
             </a:r>
-            <a:endParaRPr lang="en-US" sz="4000" dirty="0"/>
+            <a:endParaRPr lang="en-US" sz="4200" dirty="0"/>
           </a:p>
         </p:txBody>
       </p:sp>
@@ -5286,8 +5211,8 @@
         </p:nvSpPr>
         <p:spPr>
           <a:xfrm>
-            <a:off x="5888736" y="1920240"/>
-            <a:ext cx="2560320" cy="182880"/>
+            <a:off x="5705856" y="1901952"/>
+            <a:ext cx="2523744" cy="182880"/>
           </a:xfrm>
           <a:prstGeom prst="rect">
             <a:avLst/>
@@ -5329,14 +5254,13 @@
         </p:nvPicPr>
         <p:blipFill>
           <a:blip r:embed="rId1"/>
-          <a:stretch>
-            <a:fillRect/>
-          </a:stretch>
+          <a:srcRect l="0" r="0" t="0" b="0"/>
+          <a:stretch/>
         </p:blipFill>
         <p:spPr>
           <a:xfrm>
-            <a:off x="5029200" y="1261872"/>
-            <a:ext cx="3657600" cy="3566160"/>
+            <a:off x="5074920" y="1261872"/>
+            <a:ext cx="3703320" cy="3547872"/>
           </a:xfrm>
           <a:prstGeom prst="rect">
             <a:avLst/>
@@ -5352,7 +5276,7 @@
         <p:spPr>
           <a:xfrm>
             <a:off x="365760" y="2423160"/>
-            <a:ext cx="4434840" cy="2377440"/>
+            <a:ext cx="4480560" cy="2377440"/>
           </a:xfrm>
           <a:prstGeom prst="roundRect">
             <a:avLst>
@@ -5378,8 +5302,8 @@
         </p:nvSpPr>
         <p:spPr>
           <a:xfrm>
-            <a:off x="475488" y="2514600"/>
-            <a:ext cx="4206240" cy="256032"/>
+            <a:off x="484632" y="2523744"/>
+            <a:ext cx="4242816" cy="256032"/>
           </a:xfrm>
           <a:prstGeom prst="rect">
             <a:avLst/>
@@ -5417,8 +5341,8 @@
         </p:nvSpPr>
         <p:spPr>
           <a:xfrm>
-            <a:off x="475488" y="2798064"/>
-            <a:ext cx="4206240" cy="1920240"/>
+            <a:off x="484632" y="2807208"/>
+            <a:ext cx="4242816" cy="1920240"/>
           </a:xfrm>
           <a:prstGeom prst="rect">
             <a:avLst/>
@@ -5445,7 +5369,7 @@
                 <a:ea typeface="Calibri" pitchFamily="34" charset="-122"/>
                 <a:cs typeface="Calibri" pitchFamily="34" charset="-120"/>
               </a:rPr>
-              <a:t>Aplicaciones web alojadas en GitHub Pages que permiten inspecciones, registros y seguimiento en tiempo real desde cualquier dispositivo.</a:t>
+              <a:t>Aplicaciones web en GitHub Pages para inspecciones, registros y seguimiento en tiempo real desde cualquier dispositivo.</a:t>
             </a:r>
             <a:endParaRPr lang="en-US" sz="850" dirty="0"/>
           </a:p>
@@ -5580,7 +5504,7 @@
         </p:nvSpPr>
         <p:spPr>
           <a:xfrm>
-            <a:off x="365760" y="228600"/>
+            <a:off x="365760" y="201168"/>
             <a:ext cx="8412480" cy="201168"/>
           </a:xfrm>
           <a:prstGeom prst="rect">
@@ -5658,12 +5582,12 @@
         </p:nvSpPr>
         <p:spPr>
           <a:xfrm>
-            <a:off x="365760" y="1170432"/>
-            <a:ext cx="1572768" cy="1874520"/>
+            <a:off x="356616" y="1115568"/>
+            <a:ext cx="2011680" cy="1993392"/>
           </a:xfrm>
           <a:prstGeom prst="roundRect">
             <a:avLst>
-              <a:gd name="adj" fmla="val 3488"/>
+              <a:gd name="adj" fmla="val 2752"/>
             </a:avLst>
           </a:prstGeom>
           <a:solidFill>
@@ -5687,14 +5611,13 @@
         </p:nvPicPr>
         <p:blipFill>
           <a:blip r:embed="rId1"/>
-          <a:stretch>
-            <a:fillRect/>
-          </a:stretch>
+          <a:srcRect l="0" r="0" t="0" b="0"/>
+          <a:stretch/>
         </p:blipFill>
         <p:spPr>
           <a:xfrm>
-            <a:off x="365760" y="1170432"/>
-            <a:ext cx="1572768" cy="1234440"/>
+            <a:off x="356616" y="1115568"/>
+            <a:ext cx="2011680" cy="1371600"/>
           </a:xfrm>
           <a:prstGeom prst="rect">
             <a:avLst/>
@@ -5709,8 +5632,8 @@
         </p:nvSpPr>
         <p:spPr>
           <a:xfrm>
-            <a:off x="365760" y="2377440"/>
-            <a:ext cx="1572768" cy="54864"/>
+            <a:off x="356616" y="2450592"/>
+            <a:ext cx="2011680" cy="54864"/>
           </a:xfrm>
           <a:prstGeom prst="rect">
             <a:avLst/>
@@ -5734,8 +5657,8 @@
         </p:nvSpPr>
         <p:spPr>
           <a:xfrm>
-            <a:off x="438912" y="2459736"/>
-            <a:ext cx="1426464" cy="201168"/>
+            <a:off x="438912" y="2542032"/>
+            <a:ext cx="1847088" cy="201168"/>
           </a:xfrm>
           <a:prstGeom prst="rect">
             <a:avLst/>
@@ -5751,7 +5674,7 @@
               <a:buNone/>
             </a:pPr>
             <a:r>
-              <a:rPr lang="en-US" sz="850" b="1" spc="50" kern="0" dirty="0">
+              <a:rPr lang="en-US" sz="900" b="1" spc="50" kern="0" dirty="0">
                 <a:solidFill>
                   <a:srgbClr val="0D47A1"/>
                 </a:solidFill>
@@ -5761,7 +5684,7 @@
               </a:rPr>
               <a:t>INDUCCIÓN EHS</a:t>
             </a:r>
-            <a:endParaRPr lang="en-US" sz="850" dirty="0"/>
+            <a:endParaRPr lang="en-US" sz="900" dirty="0"/>
           </a:p>
         </p:txBody>
       </p:sp>
@@ -5773,8 +5696,8 @@
         </p:nvSpPr>
         <p:spPr>
           <a:xfrm>
-            <a:off x="438912" y="2660904"/>
-            <a:ext cx="1426464" cy="146304"/>
+            <a:off x="438912" y="2752344"/>
+            <a:ext cx="1847088" cy="146304"/>
           </a:xfrm>
           <a:prstGeom prst="rect">
             <a:avLst/>
@@ -5812,12 +5735,12 @@
         </p:nvSpPr>
         <p:spPr>
           <a:xfrm>
-            <a:off x="2103120" y="1170432"/>
-            <a:ext cx="1572768" cy="1874520"/>
+            <a:off x="2496312" y="1115568"/>
+            <a:ext cx="2011680" cy="1993392"/>
           </a:xfrm>
           <a:prstGeom prst="roundRect">
             <a:avLst>
-              <a:gd name="adj" fmla="val 3488"/>
+              <a:gd name="adj" fmla="val 2752"/>
             </a:avLst>
           </a:prstGeom>
           <a:solidFill>
@@ -5841,14 +5764,13 @@
         </p:nvPicPr>
         <p:blipFill>
           <a:blip r:embed="rId2"/>
-          <a:stretch>
-            <a:fillRect/>
-          </a:stretch>
+          <a:srcRect l="0" r="0" t="0" b="0"/>
+          <a:stretch/>
         </p:blipFill>
         <p:spPr>
           <a:xfrm>
-            <a:off x="2103120" y="1170432"/>
-            <a:ext cx="1572768" cy="1234440"/>
+            <a:off x="2496312" y="1115568"/>
+            <a:ext cx="2011680" cy="1371600"/>
           </a:xfrm>
           <a:prstGeom prst="rect">
             <a:avLst/>
@@ -5863,8 +5785,8 @@
         </p:nvSpPr>
         <p:spPr>
           <a:xfrm>
-            <a:off x="2103120" y="2377440"/>
-            <a:ext cx="1572768" cy="54864"/>
+            <a:off x="2496312" y="2450592"/>
+            <a:ext cx="2011680" cy="54864"/>
           </a:xfrm>
           <a:prstGeom prst="rect">
             <a:avLst/>
@@ -5888,8 +5810,8 @@
         </p:nvSpPr>
         <p:spPr>
           <a:xfrm>
-            <a:off x="2176272" y="2459736"/>
-            <a:ext cx="1426464" cy="201168"/>
+            <a:off x="2578608" y="2542032"/>
+            <a:ext cx="1847088" cy="201168"/>
           </a:xfrm>
           <a:prstGeom prst="rect">
             <a:avLst/>
@@ -5905,7 +5827,7 @@
               <a:buNone/>
             </a:pPr>
             <a:r>
-              <a:rPr lang="en-US" sz="850" b="1" spc="50" kern="0" dirty="0">
+              <a:rPr lang="en-US" sz="900" b="1" spc="50" kern="0" dirty="0">
                 <a:solidFill>
                   <a:srgbClr val="0D47A1"/>
                 </a:solidFill>
@@ -5915,7 +5837,7 @@
               </a:rPr>
               <a:t>EXTINTORES</a:t>
             </a:r>
-            <a:endParaRPr lang="en-US" sz="850" dirty="0"/>
+            <a:endParaRPr lang="en-US" sz="900" dirty="0"/>
           </a:p>
         </p:txBody>
       </p:sp>
@@ -5927,8 +5849,8 @@
         </p:nvSpPr>
         <p:spPr>
           <a:xfrm>
-            <a:off x="2176272" y="2660904"/>
-            <a:ext cx="1426464" cy="146304"/>
+            <a:off x="2578608" y="2752344"/>
+            <a:ext cx="1847088" cy="146304"/>
           </a:xfrm>
           <a:prstGeom prst="rect">
             <a:avLst/>
@@ -5966,12 +5888,12 @@
         </p:nvSpPr>
         <p:spPr>
           <a:xfrm>
-            <a:off x="3840480" y="1170432"/>
-            <a:ext cx="1572768" cy="1874520"/>
+            <a:off x="4636008" y="1115568"/>
+            <a:ext cx="2011680" cy="1993392"/>
           </a:xfrm>
           <a:prstGeom prst="roundRect">
             <a:avLst>
-              <a:gd name="adj" fmla="val 3488"/>
+              <a:gd name="adj" fmla="val 2752"/>
             </a:avLst>
           </a:prstGeom>
           <a:solidFill>
@@ -5995,14 +5917,13 @@
         </p:nvPicPr>
         <p:blipFill>
           <a:blip r:embed="rId3"/>
-          <a:stretch>
-            <a:fillRect/>
-          </a:stretch>
+          <a:srcRect l="0" r="0" t="0" b="0"/>
+          <a:stretch/>
         </p:blipFill>
         <p:spPr>
           <a:xfrm>
-            <a:off x="3840480" y="1170432"/>
-            <a:ext cx="1572768" cy="1234440"/>
+            <a:off x="4636008" y="1115568"/>
+            <a:ext cx="2011680" cy="1371600"/>
           </a:xfrm>
           <a:prstGeom prst="rect">
             <a:avLst/>
@@ -6017,8 +5938,8 @@
         </p:nvSpPr>
         <p:spPr>
           <a:xfrm>
-            <a:off x="3840480" y="2377440"/>
-            <a:ext cx="1572768" cy="54864"/>
+            <a:off x="4636008" y="2450592"/>
+            <a:ext cx="2011680" cy="54864"/>
           </a:xfrm>
           <a:prstGeom prst="rect">
             <a:avLst/>
@@ -6042,8 +5963,8 @@
         </p:nvSpPr>
         <p:spPr>
           <a:xfrm>
-            <a:off x="3913632" y="2459736"/>
-            <a:ext cx="1426464" cy="201168"/>
+            <a:off x="4718304" y="2542032"/>
+            <a:ext cx="1847088" cy="201168"/>
           </a:xfrm>
           <a:prstGeom prst="rect">
             <a:avLst/>
@@ -6059,7 +5980,7 @@
               <a:buNone/>
             </a:pPr>
             <a:r>
-              <a:rPr lang="en-US" sz="850" b="1" spc="50" kern="0" dirty="0">
+              <a:rPr lang="en-US" sz="900" b="1" spc="50" kern="0" dirty="0">
                 <a:solidFill>
                   <a:srgbClr val="0D47A1"/>
                 </a:solidFill>
@@ -6069,7 +5990,7 @@
               </a:rPr>
               <a:t>BRIGADAS</a:t>
             </a:r>
-            <a:endParaRPr lang="en-US" sz="850" dirty="0"/>
+            <a:endParaRPr lang="en-US" sz="900" dirty="0"/>
           </a:p>
         </p:txBody>
       </p:sp>
@@ -6081,8 +6002,8 @@
         </p:nvSpPr>
         <p:spPr>
           <a:xfrm>
-            <a:off x="3913632" y="2660904"/>
-            <a:ext cx="1426464" cy="146304"/>
+            <a:off x="4718304" y="2752344"/>
+            <a:ext cx="1847088" cy="146304"/>
           </a:xfrm>
           <a:prstGeom prst="rect">
             <a:avLst/>
@@ -6120,12 +6041,12 @@
         </p:nvSpPr>
         <p:spPr>
           <a:xfrm>
-            <a:off x="5577840" y="1170432"/>
-            <a:ext cx="1572768" cy="1874520"/>
+            <a:off x="6775704" y="1115568"/>
+            <a:ext cx="2011680" cy="1993392"/>
           </a:xfrm>
           <a:prstGeom prst="roundRect">
             <a:avLst>
-              <a:gd name="adj" fmla="val 3488"/>
+              <a:gd name="adj" fmla="val 2752"/>
             </a:avLst>
           </a:prstGeom>
           <a:solidFill>
@@ -6149,14 +6070,13 @@
         </p:nvPicPr>
         <p:blipFill>
           <a:blip r:embed="rId4"/>
-          <a:stretch>
-            <a:fillRect/>
-          </a:stretch>
+          <a:srcRect l="0" r="0" t="0" b="0"/>
+          <a:stretch/>
         </p:blipFill>
         <p:spPr>
           <a:xfrm>
-            <a:off x="5577840" y="1170432"/>
-            <a:ext cx="1572768" cy="1234440"/>
+            <a:off x="6775704" y="1115568"/>
+            <a:ext cx="2011680" cy="1371600"/>
           </a:xfrm>
           <a:prstGeom prst="rect">
             <a:avLst/>
@@ -6171,8 +6091,8 @@
         </p:nvSpPr>
         <p:spPr>
           <a:xfrm>
-            <a:off x="5577840" y="2377440"/>
-            <a:ext cx="1572768" cy="54864"/>
+            <a:off x="6775704" y="2450592"/>
+            <a:ext cx="2011680" cy="54864"/>
           </a:xfrm>
           <a:prstGeom prst="rect">
             <a:avLst/>
@@ -6196,8 +6116,8 @@
         </p:nvSpPr>
         <p:spPr>
           <a:xfrm>
-            <a:off x="5650992" y="2459736"/>
-            <a:ext cx="1426464" cy="201168"/>
+            <a:off x="6858000" y="2542032"/>
+            <a:ext cx="1847088" cy="201168"/>
           </a:xfrm>
           <a:prstGeom prst="rect">
             <a:avLst/>
@@ -6213,7 +6133,7 @@
               <a:buNone/>
             </a:pPr>
             <a:r>
-              <a:rPr lang="en-US" sz="850" b="1" spc="50" kern="0" dirty="0">
+              <a:rPr lang="en-US" sz="900" b="1" spc="50" kern="0" dirty="0">
                 <a:solidFill>
                   <a:srgbClr val="0D47A1"/>
                 </a:solidFill>
@@ -6223,7 +6143,7 @@
               </a:rPr>
               <a:t>IPERC</a:t>
             </a:r>
-            <a:endParaRPr lang="en-US" sz="850" dirty="0"/>
+            <a:endParaRPr lang="en-US" sz="900" dirty="0"/>
           </a:p>
         </p:txBody>
       </p:sp>
@@ -6235,8 +6155,8 @@
         </p:nvSpPr>
         <p:spPr>
           <a:xfrm>
-            <a:off x="5650992" y="2660904"/>
-            <a:ext cx="1426464" cy="146304"/>
+            <a:off x="6858000" y="2752344"/>
+            <a:ext cx="1847088" cy="146304"/>
           </a:xfrm>
           <a:prstGeom prst="rect">
             <a:avLst/>
@@ -6274,12 +6194,12 @@
         </p:nvSpPr>
         <p:spPr>
           <a:xfrm>
-            <a:off x="7315200" y="1170432"/>
-            <a:ext cx="1572768" cy="1874520"/>
+            <a:off x="1426464" y="3255264"/>
+            <a:ext cx="2011680" cy="1993392"/>
           </a:xfrm>
           <a:prstGeom prst="roundRect">
             <a:avLst>
-              <a:gd name="adj" fmla="val 3488"/>
+              <a:gd name="adj" fmla="val 2752"/>
             </a:avLst>
           </a:prstGeom>
           <a:solidFill>
@@ -6303,14 +6223,13 @@
         </p:nvPicPr>
         <p:blipFill>
           <a:blip r:embed="rId5"/>
-          <a:stretch>
-            <a:fillRect/>
-          </a:stretch>
+          <a:srcRect l="0" r="0" t="0" b="0"/>
+          <a:stretch/>
         </p:blipFill>
         <p:spPr>
           <a:xfrm>
-            <a:off x="7315200" y="1170432"/>
-            <a:ext cx="1572768" cy="1234440"/>
+            <a:off x="1426464" y="3255264"/>
+            <a:ext cx="2011680" cy="1371600"/>
           </a:xfrm>
           <a:prstGeom prst="rect">
             <a:avLst/>
@@ -6325,8 +6244,8 @@
         </p:nvSpPr>
         <p:spPr>
           <a:xfrm>
-            <a:off x="7315200" y="2377440"/>
-            <a:ext cx="1572768" cy="54864"/>
+            <a:off x="1426464" y="4590288"/>
+            <a:ext cx="2011680" cy="54864"/>
           </a:xfrm>
           <a:prstGeom prst="rect">
             <a:avLst/>
@@ -6350,8 +6269,8 @@
         </p:nvSpPr>
         <p:spPr>
           <a:xfrm>
-            <a:off x="7388352" y="2459736"/>
-            <a:ext cx="1426464" cy="201168"/>
+            <a:off x="1508760" y="4681728"/>
+            <a:ext cx="1847088" cy="201168"/>
           </a:xfrm>
           <a:prstGeom prst="rect">
             <a:avLst/>
@@ -6367,7 +6286,7 @@
               <a:buNone/>
             </a:pPr>
             <a:r>
-              <a:rPr lang="en-US" sz="850" b="1" spc="50" kern="0" dirty="0">
+              <a:rPr lang="en-US" sz="900" b="1" spc="50" kern="0" dirty="0">
                 <a:solidFill>
                   <a:srgbClr val="0D47A1"/>
                 </a:solidFill>
@@ -6377,7 +6296,7 @@
               </a:rPr>
               <a:t>APP AMBIENTE</a:t>
             </a:r>
-            <a:endParaRPr lang="en-US" sz="850" dirty="0"/>
+            <a:endParaRPr lang="en-US" sz="900" dirty="0"/>
           </a:p>
         </p:txBody>
       </p:sp>
@@ -6389,8 +6308,8 @@
         </p:nvSpPr>
         <p:spPr>
           <a:xfrm>
-            <a:off x="7388352" y="2660904"/>
-            <a:ext cx="1426464" cy="146304"/>
+            <a:off x="1508760" y="4892040"/>
+            <a:ext cx="1847088" cy="146304"/>
           </a:xfrm>
           <a:prstGeom prst="rect">
             <a:avLst/>
@@ -6415,6 +6334,312 @@
                 <a:cs typeface="Calibri" pitchFamily="34" charset="-120"/>
               </a:rPr>
               <a:t>App HTML · Seguimiento</a:t>
+            </a:r>
+            <a:endParaRPr lang="en-US" sz="700" dirty="0"/>
+          </a:p>
+        </p:txBody>
+      </p:sp>
+      <p:sp>
+        <p:nvSpPr>
+          <p:cNvPr id="29" name="Shape 22"/>
+          <p:cNvSpPr/>
+          <p:nvPr/>
+        </p:nvSpPr>
+        <p:spPr>
+          <a:xfrm>
+            <a:off x="3566160" y="3255264"/>
+            <a:ext cx="2011680" cy="1993392"/>
+          </a:xfrm>
+          <a:prstGeom prst="roundRect">
+            <a:avLst>
+              <a:gd name="adj" fmla="val 2752"/>
+            </a:avLst>
+          </a:prstGeom>
+          <a:solidFill>
+            <a:srgbClr val="FFFFFF"/>
+          </a:solidFill>
+          <a:ln w="6350">
+            <a:solidFill>
+              <a:srgbClr val="BBDEFB"/>
+            </a:solidFill>
+            <a:prstDash val="solid"/>
+          </a:ln>
+        </p:spPr>
+      </p:sp>
+      <p:pic>
+        <p:nvPicPr>
+          <p:cNvPr id="30" name="Image 5" descr="/tmp/claude-0/-home-user-kewei/9baee1fe-95ec-5175-8c53-515945a03ef9/scratchpad/pptx_build/app_inspecciones.png">    </p:cNvPr>
+          <p:cNvPicPr>
+            <a:picLocks noChangeAspect="1"/>
+          </p:cNvPicPr>
+          <p:nvPr/>
+        </p:nvPicPr>
+        <p:blipFill>
+          <a:blip r:embed="rId6"/>
+          <a:srcRect l="0" r="0" t="0" b="0"/>
+          <a:stretch/>
+        </p:blipFill>
+        <p:spPr>
+          <a:xfrm>
+            <a:off x="3566160" y="3255264"/>
+            <a:ext cx="2011680" cy="1371600"/>
+          </a:xfrm>
+          <a:prstGeom prst="rect">
+            <a:avLst/>
+          </a:prstGeom>
+        </p:spPr>
+      </p:pic>
+      <p:sp>
+        <p:nvSpPr>
+          <p:cNvPr id="31" name="Shape 23"/>
+          <p:cNvSpPr/>
+          <p:nvPr/>
+        </p:nvSpPr>
+        <p:spPr>
+          <a:xfrm>
+            <a:off x="3566160" y="4590288"/>
+            <a:ext cx="2011680" cy="54864"/>
+          </a:xfrm>
+          <a:prstGeom prst="rect">
+            <a:avLst/>
+          </a:prstGeom>
+          <a:solidFill>
+            <a:srgbClr val="1E88E5"/>
+          </a:solidFill>
+          <a:ln w="12700">
+            <a:solidFill>
+              <a:srgbClr val="1E88E5"/>
+            </a:solidFill>
+            <a:prstDash val="solid"/>
+          </a:ln>
+        </p:spPr>
+      </p:sp>
+      <p:sp>
+        <p:nvSpPr>
+          <p:cNvPr id="32" name="Text 24"/>
+          <p:cNvSpPr txBox="1"/>
+          <p:nvPr/>
+        </p:nvSpPr>
+        <p:spPr>
+          <a:xfrm>
+            <a:off x="3648456" y="4681728"/>
+            <a:ext cx="1847088" cy="201168"/>
+          </a:xfrm>
+          <a:prstGeom prst="rect">
+            <a:avLst/>
+          </a:prstGeom>
+          <a:noFill/>
+          <a:ln/>
+        </p:spPr>
+        <p:txBody>
+          <a:bodyPr wrap="square" lIns="0" tIns="0" rIns="0" bIns="0" rtlCol="0" anchor="ctr"/>
+          <a:lstStyle/>
+          <a:p>
+            <a:pPr indent="0" marL="0">
+              <a:buNone/>
+            </a:pPr>
+            <a:r>
+              <a:rPr lang="en-US" sz="900" b="1" spc="50" kern="0" dirty="0">
+                <a:solidFill>
+                  <a:srgbClr val="0D47A1"/>
+                </a:solidFill>
+                <a:latin typeface="Barlow Condensed" pitchFamily="34" charset="0"/>
+                <a:ea typeface="Barlow Condensed" pitchFamily="34" charset="-122"/>
+                <a:cs typeface="Barlow Condensed" pitchFamily="34" charset="-120"/>
+              </a:rPr>
+              <a:t>INSPECCIONES SST</a:t>
+            </a:r>
+            <a:endParaRPr lang="en-US" sz="900" dirty="0"/>
+          </a:p>
+        </p:txBody>
+      </p:sp>
+      <p:sp>
+        <p:nvSpPr>
+          <p:cNvPr id="33" name="Text 25"/>
+          <p:cNvSpPr txBox="1"/>
+          <p:nvPr/>
+        </p:nvSpPr>
+        <p:spPr>
+          <a:xfrm>
+            <a:off x="3648456" y="4892040"/>
+            <a:ext cx="1847088" cy="146304"/>
+          </a:xfrm>
+          <a:prstGeom prst="rect">
+            <a:avLst/>
+          </a:prstGeom>
+          <a:noFill/>
+          <a:ln/>
+        </p:spPr>
+        <p:txBody>
+          <a:bodyPr wrap="square" lIns="0" tIns="0" rIns="0" bIns="0" rtlCol="0" anchor="ctr"/>
+          <a:lstStyle/>
+          <a:p>
+            <a:pPr indent="0" marL="0">
+              <a:buNone/>
+            </a:pPr>
+            <a:r>
+              <a:rPr lang="en-US" sz="700" dirty="0">
+                <a:solidFill>
+                  <a:srgbClr val="546E7A"/>
+                </a:solidFill>
+                <a:latin typeface="Calibri" pitchFamily="34" charset="0"/>
+                <a:ea typeface="Calibri" pitchFamily="34" charset="-122"/>
+                <a:cs typeface="Calibri" pitchFamily="34" charset="-120"/>
+              </a:rPr>
+              <a:t>App HTML · Campo</a:t>
+            </a:r>
+            <a:endParaRPr lang="en-US" sz="700" dirty="0"/>
+          </a:p>
+        </p:txBody>
+      </p:sp>
+      <p:sp>
+        <p:nvSpPr>
+          <p:cNvPr id="34" name="Shape 26"/>
+          <p:cNvSpPr/>
+          <p:nvPr/>
+        </p:nvSpPr>
+        <p:spPr>
+          <a:xfrm>
+            <a:off x="5705856" y="3255264"/>
+            <a:ext cx="2011680" cy="1993392"/>
+          </a:xfrm>
+          <a:prstGeom prst="roundRect">
+            <a:avLst>
+              <a:gd name="adj" fmla="val 2752"/>
+            </a:avLst>
+          </a:prstGeom>
+          <a:solidFill>
+            <a:srgbClr val="FFFFFF"/>
+          </a:solidFill>
+          <a:ln w="6350">
+            <a:solidFill>
+              <a:srgbClr val="BBDEFB"/>
+            </a:solidFill>
+            <a:prstDash val="solid"/>
+          </a:ln>
+        </p:spPr>
+      </p:sp>
+      <p:pic>
+        <p:nvPicPr>
+          <p:cNvPr id="35" name="Image 6" descr="/tmp/claude-0/-home-user-kewei/9baee1fe-95ec-5175-8c53-515945a03ef9/scratchpad/pptx_build/app_evalua.png">    </p:cNvPr>
+          <p:cNvPicPr>
+            <a:picLocks noChangeAspect="1"/>
+          </p:cNvPicPr>
+          <p:nvPr/>
+        </p:nvPicPr>
+        <p:blipFill>
+          <a:blip r:embed="rId7"/>
+          <a:srcRect l="0" r="0" t="0" b="0"/>
+          <a:stretch/>
+        </p:blipFill>
+        <p:spPr>
+          <a:xfrm>
+            <a:off x="5705856" y="3255264"/>
+            <a:ext cx="2011680" cy="1371600"/>
+          </a:xfrm>
+          <a:prstGeom prst="rect">
+            <a:avLst/>
+          </a:prstGeom>
+        </p:spPr>
+      </p:pic>
+      <p:sp>
+        <p:nvSpPr>
+          <p:cNvPr id="36" name="Shape 27"/>
+          <p:cNvSpPr/>
+          <p:nvPr/>
+        </p:nvSpPr>
+        <p:spPr>
+          <a:xfrm>
+            <a:off x="5705856" y="4590288"/>
+            <a:ext cx="2011680" cy="54864"/>
+          </a:xfrm>
+          <a:prstGeom prst="rect">
+            <a:avLst/>
+          </a:prstGeom>
+          <a:solidFill>
+            <a:srgbClr val="1E88E5"/>
+          </a:solidFill>
+          <a:ln w="12700">
+            <a:solidFill>
+              <a:srgbClr val="1E88E5"/>
+            </a:solidFill>
+            <a:prstDash val="solid"/>
+          </a:ln>
+        </p:spPr>
+      </p:sp>
+      <p:sp>
+        <p:nvSpPr>
+          <p:cNvPr id="37" name="Text 28"/>
+          <p:cNvSpPr txBox="1"/>
+          <p:nvPr/>
+        </p:nvSpPr>
+        <p:spPr>
+          <a:xfrm>
+            <a:off x="5788152" y="4681728"/>
+            <a:ext cx="1847088" cy="201168"/>
+          </a:xfrm>
+          <a:prstGeom prst="rect">
+            <a:avLst/>
+          </a:prstGeom>
+          <a:noFill/>
+          <a:ln/>
+        </p:spPr>
+        <p:txBody>
+          <a:bodyPr wrap="square" lIns="0" tIns="0" rIns="0" bIns="0" rtlCol="0" anchor="ctr"/>
+          <a:lstStyle/>
+          <a:p>
+            <a:pPr indent="0" marL="0">
+              <a:buNone/>
+            </a:pPr>
+            <a:r>
+              <a:rPr lang="en-US" sz="900" b="1" spc="50" kern="0" dirty="0">
+                <a:solidFill>
+                  <a:srgbClr val="0D47A1"/>
+                </a:solidFill>
+                <a:latin typeface="Barlow Condensed" pitchFamily="34" charset="0"/>
+                <a:ea typeface="Barlow Condensed" pitchFamily="34" charset="-122"/>
+                <a:cs typeface="Barlow Condensed" pitchFamily="34" charset="-120"/>
+              </a:rPr>
+              <a:t>EVALÚA SST</a:t>
+            </a:r>
+            <a:endParaRPr lang="en-US" sz="900" dirty="0"/>
+          </a:p>
+        </p:txBody>
+      </p:sp>
+      <p:sp>
+        <p:nvSpPr>
+          <p:cNvPr id="38" name="Text 29"/>
+          <p:cNvSpPr txBox="1"/>
+          <p:nvPr/>
+        </p:nvSpPr>
+        <p:spPr>
+          <a:xfrm>
+            <a:off x="5788152" y="4892040"/>
+            <a:ext cx="1847088" cy="146304"/>
+          </a:xfrm>
+          <a:prstGeom prst="rect">
+            <a:avLst/>
+          </a:prstGeom>
+          <a:noFill/>
+          <a:ln/>
+        </p:spPr>
+        <p:txBody>
+          <a:bodyPr wrap="square" lIns="0" tIns="0" rIns="0" bIns="0" rtlCol="0" anchor="ctr"/>
+          <a:lstStyle/>
+          <a:p>
+            <a:pPr indent="0" marL="0">
+              <a:buNone/>
+            </a:pPr>
+            <a:r>
+              <a:rPr lang="en-US" sz="700" dirty="0">
+                <a:solidFill>
+                  <a:srgbClr val="546E7A"/>
+                </a:solidFill>
+                <a:latin typeface="Calibri" pitchFamily="34" charset="0"/>
+                <a:ea typeface="Calibri" pitchFamily="34" charset="-122"/>
+                <a:cs typeface="Calibri" pitchFamily="34" charset="-120"/>
+              </a:rPr>
+              <a:t>App HTML · Evaluación</a:t>
             </a:r>
             <a:endParaRPr lang="en-US" sz="700" dirty="0"/>
           </a:p>
@@ -6460,7 +6685,7 @@
         </p:nvSpPr>
         <p:spPr>
           <a:xfrm>
-            <a:off x="365760" y="228600"/>
+            <a:off x="365760" y="201168"/>
             <a:ext cx="8412480" cy="201168"/>
           </a:xfrm>
           <a:prstGeom prst="rect">
@@ -6538,12 +6763,12 @@
         </p:nvSpPr>
         <p:spPr>
           <a:xfrm>
-            <a:off x="365760" y="1234440"/>
-            <a:ext cx="8412480" cy="960120"/>
+            <a:off x="365760" y="1207008"/>
+            <a:ext cx="8412480" cy="987552"/>
           </a:xfrm>
           <a:prstGeom prst="roundRect">
             <a:avLst>
-              <a:gd name="adj" fmla="val 5714"/>
+              <a:gd name="adj" fmla="val 5556"/>
             </a:avLst>
           </a:prstGeom>
           <a:solidFill>
@@ -6565,7 +6790,7 @@
         </p:nvSpPr>
         <p:spPr>
           <a:xfrm>
-            <a:off x="502920" y="1399032"/>
+            <a:off x="512064" y="1380744"/>
             <a:ext cx="621792" cy="621792"/>
           </a:xfrm>
           <a:prstGeom prst="roundRect">
@@ -6592,7 +6817,7 @@
         </p:nvSpPr>
         <p:spPr>
           <a:xfrm>
-            <a:off x="502920" y="1399032"/>
+            <a:off x="512064" y="1380744"/>
             <a:ext cx="621792" cy="621792"/>
           </a:xfrm>
           <a:prstGeom prst="rect">
@@ -6628,8 +6853,8 @@
         </p:nvSpPr>
         <p:spPr>
           <a:xfrm>
-            <a:off x="1280160" y="1362456"/>
-            <a:ext cx="5029200" cy="219456"/>
+            <a:off x="1280160" y="1335024"/>
+            <a:ext cx="5303520" cy="237744"/>
           </a:xfrm>
           <a:prstGeom prst="rect">
             <a:avLst/>
@@ -6667,8 +6892,8 @@
         </p:nvSpPr>
         <p:spPr>
           <a:xfrm>
-            <a:off x="1280160" y="1581912"/>
-            <a:ext cx="6035040" cy="274320"/>
+            <a:off x="1280160" y="1572768"/>
+            <a:ext cx="6126480" cy="274320"/>
           </a:xfrm>
           <a:prstGeom prst="rect">
             <a:avLst/>
@@ -6692,7 +6917,7 @@
                 <a:ea typeface="Calibri" pitchFamily="34" charset="-122"/>
                 <a:cs typeface="Calibri" pitchFamily="34" charset="-120"/>
               </a:rPr>
-              <a:t>Registro y seguimiento de inspecciones de seguridad y salud en el trabajo.</a:t>
+              <a:t>Formulario de inspecciones de campo con registro automático en Google Sheets.</a:t>
             </a:r>
             <a:endParaRPr lang="en-US" sz="850" dirty="0"/>
           </a:p>
@@ -6706,8 +6931,8 @@
         </p:nvSpPr>
         <p:spPr>
           <a:xfrm>
-            <a:off x="6693408" y="1581912"/>
-            <a:ext cx="1078992" cy="219456"/>
+            <a:off x="6693408" y="1554480"/>
+            <a:ext cx="1078992" cy="237744"/>
           </a:xfrm>
           <a:prstGeom prst="roundRect">
             <a:avLst>
@@ -6716,72 +6941,6 @@
           </a:prstGeom>
           <a:solidFill>
             <a:srgbClr val="EBF4FD"/>
-          </a:solidFill>
-          <a:ln w="6350">
-            <a:solidFill>
-              <a:srgbClr val="1E88E5"/>
-            </a:solidFill>
-            <a:prstDash val="solid"/>
-          </a:ln>
-        </p:spPr>
-      </p:sp>
-      <p:sp>
-        <p:nvSpPr>
-          <p:cNvPr id="10" name="Text 8"/>
-          <p:cNvSpPr txBox="1"/>
-          <p:nvPr/>
-        </p:nvSpPr>
-        <p:spPr>
-          <a:xfrm>
-            <a:off x="6693408" y="1581912"/>
-            <a:ext cx="1078992" cy="219456"/>
-          </a:xfrm>
-          <a:prstGeom prst="rect">
-            <a:avLst/>
-          </a:prstGeom>
-          <a:noFill/>
-          <a:ln/>
-        </p:spPr>
-        <p:txBody>
-          <a:bodyPr wrap="square" lIns="0" tIns="0" rIns="0" bIns="0" rtlCol="0" anchor="ctr"/>
-          <a:lstStyle/>
-          <a:p>
-            <a:pPr algn="ctr" indent="0" marL="0">
-              <a:buNone/>
-            </a:pPr>
-            <a:r>
-              <a:rPr lang="en-US" sz="750" b="1" spc="100" kern="0" dirty="0">
-                <a:solidFill>
-                  <a:srgbClr val="0D47A1"/>
-                </a:solidFill>
-                <a:latin typeface="Barlow Condensed" pitchFamily="34" charset="0"/>
-                <a:ea typeface="Barlow Condensed" pitchFamily="34" charset="-122"/>
-                <a:cs typeface="Barlow Condensed" pitchFamily="34" charset="-120"/>
-              </a:rPr>
-              <a:t>APPS SCRIPT</a:t>
-            </a:r>
-            <a:endParaRPr lang="en-US" sz="750" dirty="0"/>
-          </a:p>
-        </p:txBody>
-      </p:sp>
-      <p:sp>
-        <p:nvSpPr>
-          <p:cNvPr id="11" name="Shape 9"/>
-          <p:cNvSpPr/>
-          <p:nvPr/>
-        </p:nvSpPr>
-        <p:spPr>
-          <a:xfrm>
-            <a:off x="365760" y="2331720"/>
-            <a:ext cx="8412480" cy="960120"/>
-          </a:xfrm>
-          <a:prstGeom prst="roundRect">
-            <a:avLst>
-              <a:gd name="adj" fmla="val 5714"/>
-            </a:avLst>
-          </a:prstGeom>
-          <a:solidFill>
-            <a:srgbClr val="FFFFFF"/>
           </a:solidFill>
           <a:ln w="6350">
             <a:solidFill>
@@ -6793,22 +6952,61 @@
       </p:sp>
       <p:sp>
         <p:nvSpPr>
-          <p:cNvPr id="12" name="Shape 10"/>
+          <p:cNvPr id="10" name="Text 8"/>
+          <p:cNvSpPr txBox="1"/>
+          <p:nvPr/>
+        </p:nvSpPr>
+        <p:spPr>
+          <a:xfrm>
+            <a:off x="6693408" y="1554480"/>
+            <a:ext cx="1078992" cy="237744"/>
+          </a:xfrm>
+          <a:prstGeom prst="rect">
+            <a:avLst/>
+          </a:prstGeom>
+          <a:noFill/>
+          <a:ln/>
+        </p:spPr>
+        <p:txBody>
+          <a:bodyPr wrap="square" lIns="0" tIns="0" rIns="0" bIns="0" rtlCol="0" anchor="ctr"/>
+          <a:lstStyle/>
+          <a:p>
+            <a:pPr algn="ctr" indent="0" marL="0">
+              <a:buNone/>
+            </a:pPr>
+            <a:r>
+              <a:rPr lang="en-US" sz="750" b="1" spc="100" kern="0" dirty="0">
+                <a:solidFill>
+                  <a:srgbClr val="0D47A1"/>
+                </a:solidFill>
+                <a:latin typeface="Barlow Condensed" pitchFamily="34" charset="0"/>
+                <a:ea typeface="Barlow Condensed" pitchFamily="34" charset="-122"/>
+                <a:cs typeface="Barlow Condensed" pitchFamily="34" charset="-120"/>
+              </a:rPr>
+              <a:t>APPS SCRIPT</a:t>
+            </a:r>
+            <a:endParaRPr lang="en-US" sz="750" dirty="0"/>
+          </a:p>
+        </p:txBody>
+      </p:sp>
+      <p:sp>
+        <p:nvSpPr>
+          <p:cNvPr id="11" name="Shape 9"/>
           <p:cNvSpPr/>
           <p:nvPr/>
         </p:nvSpPr>
         <p:spPr>
           <a:xfrm>
-            <a:off x="502920" y="2496312"/>
-            <a:ext cx="621792" cy="621792"/>
+            <a:off x="365760" y="2322576"/>
+            <a:ext cx="8412480" cy="987552"/>
           </a:xfrm>
           <a:prstGeom prst="roundRect">
             <a:avLst>
-              <a:gd name="adj" fmla="val 8824"/>
+              <a:gd name="adj" fmla="val 5556"/>
             </a:avLst>
           </a:prstGeom>
           <a:solidFill>
-            <a:srgbClr val="EBF4FD"/>
+            <a:srgbClr val="FFFFFF"/>
           </a:solidFill>
           <a:ln w="6350">
             <a:solidFill>
@@ -6820,202 +7018,22 @@
       </p:sp>
       <p:sp>
         <p:nvSpPr>
-          <p:cNvPr id="13" name="Text 11"/>
-          <p:cNvSpPr txBox="1"/>
-          <p:nvPr/>
-        </p:nvSpPr>
-        <p:spPr>
-          <a:xfrm>
-            <a:off x="502920" y="2496312"/>
+          <p:cNvPr id="12" name="Shape 10"/>
+          <p:cNvSpPr/>
+          <p:nvPr/>
+        </p:nvSpPr>
+        <p:spPr>
+          <a:xfrm>
+            <a:off x="512064" y="2496312"/>
             <a:ext cx="621792" cy="621792"/>
-          </a:xfrm>
-          <a:prstGeom prst="rect">
-            <a:avLst/>
-          </a:prstGeom>
-          <a:noFill/>
-          <a:ln/>
-        </p:spPr>
-        <p:txBody>
-          <a:bodyPr wrap="square" lIns="0" tIns="0" rIns="0" bIns="0" rtlCol="0" anchor="ctr"/>
-          <a:lstStyle/>
-          <a:p>
-            <a:pPr algn="ctr" indent="0" marL="0">
-              <a:buNone/>
-            </a:pPr>
-            <a:r>
-              <a:rPr lang="en-US" sz="2000" dirty="0">
-                <a:solidFill>
-                  <a:srgbClr val="000000"/>
-                </a:solidFill>
-              </a:rPr>
-              <a:t>📋</a:t>
-            </a:r>
-            <a:endParaRPr lang="en-US" sz="2000" dirty="0"/>
-          </a:p>
-        </p:txBody>
-      </p:sp>
-      <p:sp>
-        <p:nvSpPr>
-          <p:cNvPr id="14" name="Text 12"/>
-          <p:cNvSpPr txBox="1"/>
-          <p:nvPr/>
-        </p:nvSpPr>
-        <p:spPr>
-          <a:xfrm>
-            <a:off x="1280160" y="2459736"/>
-            <a:ext cx="5029200" cy="219456"/>
-          </a:xfrm>
-          <a:prstGeom prst="rect">
-            <a:avLst/>
-          </a:prstGeom>
-          <a:noFill/>
-          <a:ln/>
-        </p:spPr>
-        <p:txBody>
-          <a:bodyPr wrap="square" lIns="0" tIns="0" rIns="0" bIns="0" rtlCol="0" anchor="ctr"/>
-          <a:lstStyle/>
-          <a:p>
-            <a:pPr indent="0" marL="0">
-              <a:buNone/>
-            </a:pPr>
-            <a:r>
-              <a:rPr lang="en-US" sz="1300" b="1" dirty="0">
-                <a:solidFill>
-                  <a:srgbClr val="0D47A1"/>
-                </a:solidFill>
-                <a:latin typeface="Barlow Condensed" pitchFamily="34" charset="0"/>
-                <a:ea typeface="Barlow Condensed" pitchFamily="34" charset="-122"/>
-                <a:cs typeface="Barlow Condensed" pitchFamily="34" charset="-120"/>
-              </a:rPr>
-              <a:t>Evalúa SST</a:t>
-            </a:r>
-            <a:endParaRPr lang="en-US" sz="1300" dirty="0"/>
-          </a:p>
-        </p:txBody>
-      </p:sp>
-      <p:sp>
-        <p:nvSpPr>
-          <p:cNvPr id="15" name="Text 13"/>
-          <p:cNvSpPr txBox="1"/>
-          <p:nvPr/>
-        </p:nvSpPr>
-        <p:spPr>
-          <a:xfrm>
-            <a:off x="1280160" y="2679192"/>
-            <a:ext cx="6035040" cy="274320"/>
-          </a:xfrm>
-          <a:prstGeom prst="rect">
-            <a:avLst/>
-          </a:prstGeom>
-          <a:noFill/>
-          <a:ln/>
-        </p:spPr>
-        <p:txBody>
-          <a:bodyPr wrap="square" lIns="0" tIns="0" rIns="0" bIns="0" rtlCol="0" anchor="ctr"/>
-          <a:lstStyle/>
-          <a:p>
-            <a:pPr indent="0" marL="0">
-              <a:buNone/>
-            </a:pPr>
-            <a:r>
-              <a:rPr lang="en-US" sz="850" dirty="0">
-                <a:solidFill>
-                  <a:srgbClr val="546E7A"/>
-                </a:solidFill>
-                <a:latin typeface="Calibri" pitchFamily="34" charset="0"/>
-                <a:ea typeface="Calibri" pitchFamily="34" charset="-122"/>
-                <a:cs typeface="Calibri" pitchFamily="34" charset="-120"/>
-              </a:rPr>
-              <a:t>Evaluación de condiciones de seguridad y generación de reportes automáticos.</a:t>
-            </a:r>
-            <a:endParaRPr lang="en-US" sz="850" dirty="0"/>
-          </a:p>
-        </p:txBody>
-      </p:sp>
-      <p:sp>
-        <p:nvSpPr>
-          <p:cNvPr id="16" name="Shape 14"/>
-          <p:cNvSpPr/>
-          <p:nvPr/>
-        </p:nvSpPr>
-        <p:spPr>
-          <a:xfrm>
-            <a:off x="6620256" y="2679192"/>
-            <a:ext cx="1152144" cy="219456"/>
           </a:xfrm>
           <a:prstGeom prst="roundRect">
             <a:avLst>
-              <a:gd name="adj" fmla="val 50000"/>
+              <a:gd name="adj" fmla="val 8824"/>
             </a:avLst>
           </a:prstGeom>
           <a:solidFill>
             <a:srgbClr val="EBF4FD"/>
-          </a:solidFill>
-          <a:ln w="6350">
-            <a:solidFill>
-              <a:srgbClr val="1E88E5"/>
-            </a:solidFill>
-            <a:prstDash val="solid"/>
-          </a:ln>
-        </p:spPr>
-      </p:sp>
-      <p:sp>
-        <p:nvSpPr>
-          <p:cNvPr id="17" name="Text 15"/>
-          <p:cNvSpPr txBox="1"/>
-          <p:nvPr/>
-        </p:nvSpPr>
-        <p:spPr>
-          <a:xfrm>
-            <a:off x="6620256" y="2679192"/>
-            <a:ext cx="1152144" cy="219456"/>
-          </a:xfrm>
-          <a:prstGeom prst="rect">
-            <a:avLst/>
-          </a:prstGeom>
-          <a:noFill/>
-          <a:ln/>
-        </p:spPr>
-        <p:txBody>
-          <a:bodyPr wrap="square" lIns="0" tIns="0" rIns="0" bIns="0" rtlCol="0" anchor="ctr"/>
-          <a:lstStyle/>
-          <a:p>
-            <a:pPr algn="ctr" indent="0" marL="0">
-              <a:buNone/>
-            </a:pPr>
-            <a:r>
-              <a:rPr lang="en-US" sz="750" b="1" spc="100" kern="0" dirty="0">
-                <a:solidFill>
-                  <a:srgbClr val="0D47A1"/>
-                </a:solidFill>
-                <a:latin typeface="Barlow Condensed" pitchFamily="34" charset="0"/>
-                <a:ea typeface="Barlow Condensed" pitchFamily="34" charset="-122"/>
-                <a:cs typeface="Barlow Condensed" pitchFamily="34" charset="-120"/>
-              </a:rPr>
-              <a:t>GOOGLE FORMS</a:t>
-            </a:r>
-            <a:endParaRPr lang="en-US" sz="750" dirty="0"/>
-          </a:p>
-        </p:txBody>
-      </p:sp>
-      <p:sp>
-        <p:nvSpPr>
-          <p:cNvPr id="18" name="Shape 16"/>
-          <p:cNvSpPr/>
-          <p:nvPr/>
-        </p:nvSpPr>
-        <p:spPr>
-          <a:xfrm>
-            <a:off x="365760" y="3429000"/>
-            <a:ext cx="8412480" cy="960120"/>
-          </a:xfrm>
-          <a:prstGeom prst="roundRect">
-            <a:avLst>
-              <a:gd name="adj" fmla="val 5714"/>
-            </a:avLst>
-          </a:prstGeom>
-          <a:solidFill>
-            <a:srgbClr val="FFFFFF"/>
           </a:solidFill>
           <a:ln w="6350">
             <a:solidFill>
@@ -7027,18 +7045,132 @@
       </p:sp>
       <p:sp>
         <p:nvSpPr>
-          <p:cNvPr id="19" name="Shape 17"/>
+          <p:cNvPr id="13" name="Text 11"/>
+          <p:cNvSpPr txBox="1"/>
+          <p:nvPr/>
+        </p:nvSpPr>
+        <p:spPr>
+          <a:xfrm>
+            <a:off x="512064" y="2496312"/>
+            <a:ext cx="621792" cy="621792"/>
+          </a:xfrm>
+          <a:prstGeom prst="rect">
+            <a:avLst/>
+          </a:prstGeom>
+          <a:noFill/>
+          <a:ln/>
+        </p:spPr>
+        <p:txBody>
+          <a:bodyPr wrap="square" lIns="0" tIns="0" rIns="0" bIns="0" rtlCol="0" anchor="ctr"/>
+          <a:lstStyle/>
+          <a:p>
+            <a:pPr algn="ctr" indent="0" marL="0">
+              <a:buNone/>
+            </a:pPr>
+            <a:r>
+              <a:rPr lang="en-US" sz="2000" dirty="0">
+                <a:solidFill>
+                  <a:srgbClr val="000000"/>
+                </a:solidFill>
+              </a:rPr>
+              <a:t>📋</a:t>
+            </a:r>
+            <a:endParaRPr lang="en-US" sz="2000" dirty="0"/>
+          </a:p>
+        </p:txBody>
+      </p:sp>
+      <p:sp>
+        <p:nvSpPr>
+          <p:cNvPr id="14" name="Text 12"/>
+          <p:cNvSpPr txBox="1"/>
+          <p:nvPr/>
+        </p:nvSpPr>
+        <p:spPr>
+          <a:xfrm>
+            <a:off x="1280160" y="2450592"/>
+            <a:ext cx="5303520" cy="237744"/>
+          </a:xfrm>
+          <a:prstGeom prst="rect">
+            <a:avLst/>
+          </a:prstGeom>
+          <a:noFill/>
+          <a:ln/>
+        </p:spPr>
+        <p:txBody>
+          <a:bodyPr wrap="square" lIns="0" tIns="0" rIns="0" bIns="0" rtlCol="0" anchor="ctr"/>
+          <a:lstStyle/>
+          <a:p>
+            <a:pPr indent="0" marL="0">
+              <a:buNone/>
+            </a:pPr>
+            <a:r>
+              <a:rPr lang="en-US" sz="1300" b="1" dirty="0">
+                <a:solidFill>
+                  <a:srgbClr val="0D47A1"/>
+                </a:solidFill>
+                <a:latin typeface="Barlow Condensed" pitchFamily="34" charset="0"/>
+                <a:ea typeface="Barlow Condensed" pitchFamily="34" charset="-122"/>
+                <a:cs typeface="Barlow Condensed" pitchFamily="34" charset="-120"/>
+              </a:rPr>
+              <a:t>Evalúa SST</a:t>
+            </a:r>
+            <a:endParaRPr lang="en-US" sz="1300" dirty="0"/>
+          </a:p>
+        </p:txBody>
+      </p:sp>
+      <p:sp>
+        <p:nvSpPr>
+          <p:cNvPr id="15" name="Text 13"/>
+          <p:cNvSpPr txBox="1"/>
+          <p:nvPr/>
+        </p:nvSpPr>
+        <p:spPr>
+          <a:xfrm>
+            <a:off x="1280160" y="2688336"/>
+            <a:ext cx="6126480" cy="274320"/>
+          </a:xfrm>
+          <a:prstGeom prst="rect">
+            <a:avLst/>
+          </a:prstGeom>
+          <a:noFill/>
+          <a:ln/>
+        </p:spPr>
+        <p:txBody>
+          <a:bodyPr wrap="square" lIns="0" tIns="0" rIns="0" bIns="0" rtlCol="0" anchor="ctr"/>
+          <a:lstStyle/>
+          <a:p>
+            <a:pPr indent="0" marL="0">
+              <a:buNone/>
+            </a:pPr>
+            <a:r>
+              <a:rPr lang="en-US" sz="850" dirty="0">
+                <a:solidFill>
+                  <a:srgbClr val="546E7A"/>
+                </a:solidFill>
+                <a:latin typeface="Calibri" pitchFamily="34" charset="0"/>
+                <a:ea typeface="Calibri" pitchFamily="34" charset="-122"/>
+                <a:cs typeface="Calibri" pitchFamily="34" charset="-120"/>
+              </a:rPr>
+              <a:t>Evaluación de conocimientos en seguridad para personal operativo con puntaje automático.</a:t>
+            </a:r>
+            <a:endParaRPr lang="en-US" sz="850" dirty="0"/>
+          </a:p>
+        </p:txBody>
+      </p:sp>
+      <p:sp>
+        <p:nvSpPr>
+          <p:cNvPr id="16" name="Shape 14"/>
           <p:cNvSpPr/>
           <p:nvPr/>
         </p:nvSpPr>
         <p:spPr>
           <a:xfrm>
-            <a:off x="502920" y="3593592"/>
-            <a:ext cx="621792" cy="621792"/>
+            <a:off x="6693408" y="2670048"/>
+            <a:ext cx="1078992" cy="237744"/>
           </a:xfrm>
           <a:prstGeom prst="roundRect">
             <a:avLst>
-              <a:gd name="adj" fmla="val 8824"/>
+              <a:gd name="adj" fmla="val 50000"/>
             </a:avLst>
           </a:prstGeom>
           <a:solidFill>
@@ -7054,14 +7186,14 @@
       </p:sp>
       <p:sp>
         <p:nvSpPr>
-          <p:cNvPr id="20" name="Text 18"/>
-          <p:cNvSpPr txBox="1"/>
-          <p:nvPr/>
-        </p:nvSpPr>
-        <p:spPr>
-          <a:xfrm>
-            <a:off x="502920" y="3593592"/>
-            <a:ext cx="621792" cy="621792"/>
+          <p:cNvPr id="17" name="Text 15"/>
+          <p:cNvSpPr txBox="1"/>
+          <p:nvPr/>
+        </p:nvSpPr>
+        <p:spPr>
+          <a:xfrm>
+            <a:off x="6693408" y="2670048"/>
+            <a:ext cx="1078992" cy="237744"/>
           </a:xfrm>
           <a:prstGeom prst="rect">
             <a:avLst/>
@@ -7077,43 +7209,7 @@
               <a:buNone/>
             </a:pPr>
             <a:r>
-              <a:rPr lang="en-US" sz="2000" dirty="0">
-                <a:solidFill>
-                  <a:srgbClr val="000000"/>
-                </a:solidFill>
-              </a:rPr>
-              <a:t>♻️</a:t>
-            </a:r>
-            <a:endParaRPr lang="en-US" sz="2000" dirty="0"/>
-          </a:p>
-        </p:txBody>
-      </p:sp>
-      <p:sp>
-        <p:nvSpPr>
-          <p:cNvPr id="21" name="Text 19"/>
-          <p:cNvSpPr txBox="1"/>
-          <p:nvPr/>
-        </p:nvSpPr>
-        <p:spPr>
-          <a:xfrm>
-            <a:off x="1280160" y="3557016"/>
-            <a:ext cx="5029200" cy="219456"/>
-          </a:xfrm>
-          <a:prstGeom prst="rect">
-            <a:avLst/>
-          </a:prstGeom>
-          <a:noFill/>
-          <a:ln/>
-        </p:spPr>
-        <p:txBody>
-          <a:bodyPr wrap="square" lIns="0" tIns="0" rIns="0" bIns="0" rtlCol="0" anchor="ctr"/>
-          <a:lstStyle/>
-          <a:p>
-            <a:pPr indent="0" marL="0">
-              <a:buNone/>
-            </a:pPr>
-            <a:r>
-              <a:rPr lang="en-US" sz="1300" b="1" dirty="0">
+              <a:rPr lang="en-US" sz="750" b="1" spc="100" kern="0" dirty="0">
                 <a:solidFill>
                   <a:srgbClr val="0D47A1"/>
                 </a:solidFill>
@@ -7121,6 +7217,135 @@
                 <a:ea typeface="Barlow Condensed" pitchFamily="34" charset="-122"/>
                 <a:cs typeface="Barlow Condensed" pitchFamily="34" charset="-120"/>
               </a:rPr>
+              <a:t>APPS SCRIPT</a:t>
+            </a:r>
+            <a:endParaRPr lang="en-US" sz="750" dirty="0"/>
+          </a:p>
+        </p:txBody>
+      </p:sp>
+      <p:sp>
+        <p:nvSpPr>
+          <p:cNvPr id="18" name="Shape 16"/>
+          <p:cNvSpPr/>
+          <p:nvPr/>
+        </p:nvSpPr>
+        <p:spPr>
+          <a:xfrm>
+            <a:off x="365760" y="3438144"/>
+            <a:ext cx="8412480" cy="987552"/>
+          </a:xfrm>
+          <a:prstGeom prst="roundRect">
+            <a:avLst>
+              <a:gd name="adj" fmla="val 5556"/>
+            </a:avLst>
+          </a:prstGeom>
+          <a:solidFill>
+            <a:srgbClr val="FFFFFF"/>
+          </a:solidFill>
+          <a:ln w="6350">
+            <a:solidFill>
+              <a:srgbClr val="BBDEFB"/>
+            </a:solidFill>
+            <a:prstDash val="solid"/>
+          </a:ln>
+        </p:spPr>
+      </p:sp>
+      <p:sp>
+        <p:nvSpPr>
+          <p:cNvPr id="19" name="Shape 17"/>
+          <p:cNvSpPr/>
+          <p:nvPr/>
+        </p:nvSpPr>
+        <p:spPr>
+          <a:xfrm>
+            <a:off x="512064" y="3611880"/>
+            <a:ext cx="621792" cy="621792"/>
+          </a:xfrm>
+          <a:prstGeom prst="roundRect">
+            <a:avLst>
+              <a:gd name="adj" fmla="val 8824"/>
+            </a:avLst>
+          </a:prstGeom>
+          <a:solidFill>
+            <a:srgbClr val="EBF4FD"/>
+          </a:solidFill>
+          <a:ln w="6350">
+            <a:solidFill>
+              <a:srgbClr val="BBDEFB"/>
+            </a:solidFill>
+            <a:prstDash val="solid"/>
+          </a:ln>
+        </p:spPr>
+      </p:sp>
+      <p:sp>
+        <p:nvSpPr>
+          <p:cNvPr id="20" name="Text 18"/>
+          <p:cNvSpPr txBox="1"/>
+          <p:nvPr/>
+        </p:nvSpPr>
+        <p:spPr>
+          <a:xfrm>
+            <a:off x="512064" y="3611880"/>
+            <a:ext cx="621792" cy="621792"/>
+          </a:xfrm>
+          <a:prstGeom prst="rect">
+            <a:avLst/>
+          </a:prstGeom>
+          <a:noFill/>
+          <a:ln/>
+        </p:spPr>
+        <p:txBody>
+          <a:bodyPr wrap="square" lIns="0" tIns="0" rIns="0" bIns="0" rtlCol="0" anchor="ctr"/>
+          <a:lstStyle/>
+          <a:p>
+            <a:pPr algn="ctr" indent="0" marL="0">
+              <a:buNone/>
+            </a:pPr>
+            <a:r>
+              <a:rPr lang="en-US" sz="2000" dirty="0">
+                <a:solidFill>
+                  <a:srgbClr val="000000"/>
+                </a:solidFill>
+              </a:rPr>
+              <a:t>♻️</a:t>
+            </a:r>
+            <a:endParaRPr lang="en-US" sz="2000" dirty="0"/>
+          </a:p>
+        </p:txBody>
+      </p:sp>
+      <p:sp>
+        <p:nvSpPr>
+          <p:cNvPr id="21" name="Text 19"/>
+          <p:cNvSpPr txBox="1"/>
+          <p:nvPr/>
+        </p:nvSpPr>
+        <p:spPr>
+          <a:xfrm>
+            <a:off x="1280160" y="3566160"/>
+            <a:ext cx="5303520" cy="237744"/>
+          </a:xfrm>
+          <a:prstGeom prst="rect">
+            <a:avLst/>
+          </a:prstGeom>
+          <a:noFill/>
+          <a:ln/>
+        </p:spPr>
+        <p:txBody>
+          <a:bodyPr wrap="square" lIns="0" tIns="0" rIns="0" bIns="0" rtlCol="0" anchor="ctr"/>
+          <a:lstStyle/>
+          <a:p>
+            <a:pPr indent="0" marL="0">
+              <a:buNone/>
+            </a:pPr>
+            <a:r>
+              <a:rPr lang="en-US" sz="1300" b="1" dirty="0">
+                <a:solidFill>
+                  <a:srgbClr val="0D47A1"/>
+                </a:solidFill>
+                <a:latin typeface="Barlow Condensed" pitchFamily="34" charset="0"/>
+                <a:ea typeface="Barlow Condensed" pitchFamily="34" charset="-122"/>
+                <a:cs typeface="Barlow Condensed" pitchFamily="34" charset="-120"/>
+              </a:rPr>
               <a:t>Auditoría de Segregación</a:t>
             </a:r>
             <a:endParaRPr lang="en-US" sz="1300" dirty="0"/>
@@ -7135,8 +7360,8 @@
         </p:nvSpPr>
         <p:spPr>
           <a:xfrm>
-            <a:off x="1280160" y="3776472"/>
-            <a:ext cx="6035040" cy="274320"/>
+            <a:off x="1280160" y="3803904"/>
+            <a:ext cx="6126480" cy="274320"/>
           </a:xfrm>
           <a:prstGeom prst="rect">
             <a:avLst/>
@@ -7174,8 +7399,8 @@
         </p:nvSpPr>
         <p:spPr>
           <a:xfrm>
-            <a:off x="6547104" y="3776472"/>
-            <a:ext cx="1225296" cy="219456"/>
+            <a:off x="6547104" y="3785616"/>
+            <a:ext cx="1225296" cy="237744"/>
           </a:xfrm>
           <a:prstGeom prst="roundRect">
             <a:avLst>
@@ -7201,8 +7426,8 @@
         </p:nvSpPr>
         <p:spPr>
           <a:xfrm>
-            <a:off x="6547104" y="3776472"/>
-            <a:ext cx="1225296" cy="219456"/>
+            <a:off x="6547104" y="3785616"/>
+            <a:ext cx="1225296" cy="237744"/>
           </a:xfrm>
           <a:prstGeom prst="rect">
             <a:avLst/>

</xml_diff>

<commit_message>
Fix PPTX corruption — remove emoji from XML (slide 8 icon text)
Emoji codepoints (U+1F50D, U+1F4CB, U+267B) in pptx XML text nodes
cause PowerPoint to report the file as corrupt. Replaced with safe
ASCII abbreviations: INS, EVA, AUD.

Co-Authored-By: Claude Sonnet 4.6 <noreply@anthropic.com>
Claude-Session: https://claude.ai/code/session_01XvhWRdRzmvfoAaer6LAorC
</commit_message>
<xml_diff>
--- a/Reporte_SST_Semana36.pptx
+++ b/Reporte_SST_Semana36.pptx
@@ -6834,14 +6834,17 @@
               <a:buNone/>
             </a:pPr>
             <a:r>
-              <a:rPr lang="en-US" sz="2000" dirty="0">
-                <a:solidFill>
-                  <a:srgbClr val="000000"/>
-                </a:solidFill>
-              </a:rPr>
-              <a:t>🔍</a:t>
-            </a:r>
-            <a:endParaRPr lang="en-US" sz="2000" dirty="0"/>
+              <a:rPr lang="en-US" sz="1300" b="1" dirty="0">
+                <a:solidFill>
+                  <a:srgbClr val="0D47A1"/>
+                </a:solidFill>
+                <a:latin typeface="Barlow Condensed" pitchFamily="34" charset="0"/>
+                <a:ea typeface="Barlow Condensed" pitchFamily="34" charset="-122"/>
+                <a:cs typeface="Barlow Condensed" pitchFamily="34" charset="-120"/>
+              </a:rPr>
+              <a:t>INS</a:t>
+            </a:r>
+            <a:endParaRPr lang="en-US" sz="1300" dirty="0"/>
           </a:p>
         </p:txBody>
       </p:sp>
@@ -7068,14 +7071,17 @@
               <a:buNone/>
             </a:pPr>
             <a:r>
-              <a:rPr lang="en-US" sz="2000" dirty="0">
-                <a:solidFill>
-                  <a:srgbClr val="000000"/>
-                </a:solidFill>
-              </a:rPr>
-              <a:t>📋</a:t>
-            </a:r>
-            <a:endParaRPr lang="en-US" sz="2000" dirty="0"/>
+              <a:rPr lang="en-US" sz="1300" b="1" dirty="0">
+                <a:solidFill>
+                  <a:srgbClr val="0D47A1"/>
+                </a:solidFill>
+                <a:latin typeface="Barlow Condensed" pitchFamily="34" charset="0"/>
+                <a:ea typeface="Barlow Condensed" pitchFamily="34" charset="-122"/>
+                <a:cs typeface="Barlow Condensed" pitchFamily="34" charset="-120"/>
+              </a:rPr>
+              <a:t>EVA</a:t>
+            </a:r>
+            <a:endParaRPr lang="en-US" sz="1300" dirty="0"/>
           </a:p>
         </p:txBody>
       </p:sp>
@@ -7302,14 +7308,17 @@
               <a:buNone/>
             </a:pPr>
             <a:r>
-              <a:rPr lang="en-US" sz="2000" dirty="0">
-                <a:solidFill>
-                  <a:srgbClr val="000000"/>
-                </a:solidFill>
-              </a:rPr>
-              <a:t>♻️</a:t>
-            </a:r>
-            <a:endParaRPr lang="en-US" sz="2000" dirty="0"/>
+              <a:rPr lang="en-US" sz="1300" b="1" dirty="0">
+                <a:solidFill>
+                  <a:srgbClr val="0D47A1"/>
+                </a:solidFill>
+                <a:latin typeface="Barlow Condensed" pitchFamily="34" charset="0"/>
+                <a:ea typeface="Barlow Condensed" pitchFamily="34" charset="-122"/>
+                <a:cs typeface="Barlow Condensed" pitchFamily="34" charset="-120"/>
+              </a:rPr>
+              <a:t>AUD</a:t>
+            </a:r>
+            <a:endParaRPr lang="en-US" sz="1300" dirty="0"/>
           </a:p>
         </p:txBody>
       </p:sp>

</xml_diff>